<commit_message>
Deck v3: 21-slide version with Jaeger refs + hire-me CTA
</commit_message>
<xml_diff>
--- a/Hands-On-ish_LLMOps.pptx
+++ b/Hands-On-ish_LLMOps.pptx
@@ -2,61 +2,57 @@
 <file path=ppt/presentation.xml><?xml version="1.0" encoding="utf-8"?>
 <p:presentation xmlns:a="http://schemas.openxmlformats.org/drawingml/2006/main" xmlns:r="http://schemas.openxmlformats.org/officeDocument/2006/relationships" xmlns:mc="http://schemas.openxmlformats.org/markup-compatibility/2006" xmlns:mv="urn:schemas-microsoft-com:mac:vml" xmlns:p="http://schemas.openxmlformats.org/presentationml/2006/main" xmlns:c="http://schemas.openxmlformats.org/drawingml/2006/chart" xmlns:dgm="http://schemas.openxmlformats.org/drawingml/2006/diagram" xmlns:o="urn:schemas-microsoft-com:office:office" xmlns:v="urn:schemas-microsoft-com:vml" xmlns:pvml="urn:schemas-microsoft-com:office:powerpoint" xmlns:com="http://schemas.openxmlformats.org/drawingml/2006/compatibility" xmlns:p14="http://schemas.microsoft.com/office/powerpoint/2010/main" xmlns:p15="http://schemas.microsoft.com/office/powerpoint/2012/main" xmlns:ahyp="http://schemas.microsoft.com/office/drawing/2018/hyperlinkcolor" autoCompressPictures="0" embedTrueTypeFonts="1" strictFirstAndLastChars="0" saveSubsetFonts="1">
   <p:sldMasterIdLst>
-    <p:sldMasterId id="2147483649" r:id="rId3"/>
+    <p:sldMasterId id="2147483649" r:id="rId4"/>
   </p:sldMasterIdLst>
   <p:notesMasterIdLst>
-    <p:notesMasterId r:id="rId4"/>
+    <p:notesMasterId r:id="rId5"/>
   </p:notesMasterIdLst>
   <p:sldIdLst>
-    <p:sldId id="256" r:id="rId5"/>
-    <p:sldId id="257" r:id="rId6"/>
-    <p:sldId id="258" r:id="rId7"/>
-    <p:sldId id="259" r:id="rId8"/>
-    <p:sldId id="260" r:id="rId9"/>
-    <p:sldId id="261" r:id="rId10"/>
-    <p:sldId id="262" r:id="rId11"/>
-    <p:sldId id="263" r:id="rId12"/>
-    <p:sldId id="264" r:id="rId13"/>
-    <p:sldId id="277" r:id="rId38"/>
-    <p:sldId id="278" r:id="rId39"/>
-    <p:sldId id="279" r:id="rId40"/>
-    <p:sldId id="280" r:id="rId41"/>
-    <p:sldId id="265" r:id="rId14"/>
-    <p:sldId id="266" r:id="rId15"/>
-    <p:sldId id="267" r:id="rId16"/>
-    <p:sldId id="268" r:id="rId17"/>
-    <p:sldId id="269" r:id="rId18"/>
-    <p:sldId id="270" r:id="rId19"/>
-    <p:sldId id="271" r:id="rId20"/>
-    <p:sldId id="272" r:id="rId21"/>
-    <p:sldId id="273" r:id="rId22"/>
-    <p:sldId id="274" r:id="rId23"/>
-    <p:sldId id="275" r:id="rId24"/>
-    <p:sldId id="276" r:id="rId25"/>
+    <p:sldId id="256" r:id="rId6"/>
+    <p:sldId id="257" r:id="rId7"/>
+    <p:sldId id="258" r:id="rId8"/>
+    <p:sldId id="259" r:id="rId9"/>
+    <p:sldId id="260" r:id="rId10"/>
+    <p:sldId id="261" r:id="rId11"/>
+    <p:sldId id="262" r:id="rId12"/>
+    <p:sldId id="263" r:id="rId13"/>
+    <p:sldId id="264" r:id="rId14"/>
+    <p:sldId id="265" r:id="rId15"/>
+    <p:sldId id="266" r:id="rId16"/>
+    <p:sldId id="267" r:id="rId17"/>
+    <p:sldId id="268" r:id="rId18"/>
+    <p:sldId id="269" r:id="rId19"/>
+    <p:sldId id="270" r:id="rId20"/>
+    <p:sldId id="271" r:id="rId21"/>
+    <p:sldId id="272" r:id="rId22"/>
+    <p:sldId id="273" r:id="rId23"/>
+    <p:sldId id="274" r:id="rId24"/>
+    <p:sldId id="275" r:id="rId25"/>
+    <p:sldId id="276" r:id="rId26"/>
   </p:sldIdLst>
   <p:sldSz cy="6858000" cx="12192000"/>
   <p:notesSz cx="6858000" cy="12192000"/>
   <p:embeddedFontLst>
     <p:embeddedFont>
       <p:font typeface="Roboto"/>
-      <p:regular r:id="rId26"/>
-      <p:bold r:id="rId27"/>
-      <p:italic r:id="rId28"/>
-      <p:boldItalic r:id="rId29"/>
+      <p:regular r:id="rId27"/>
+      <p:bold r:id="rId28"/>
+      <p:italic r:id="rId29"/>
+      <p:boldItalic r:id="rId30"/>
     </p:embeddedFont>
     <p:embeddedFont>
       <p:font typeface="Lato"/>
-      <p:regular r:id="rId30"/>
-      <p:bold r:id="rId31"/>
-      <p:italic r:id="rId32"/>
-      <p:boldItalic r:id="rId33"/>
+      <p:regular r:id="rId31"/>
+      <p:bold r:id="rId32"/>
+      <p:italic r:id="rId33"/>
+      <p:boldItalic r:id="rId34"/>
     </p:embeddedFont>
     <p:embeddedFont>
       <p:font typeface="Spectral"/>
-      <p:regular r:id="rId34"/>
-      <p:bold r:id="rId35"/>
-      <p:italic r:id="rId36"/>
-      <p:boldItalic r:id="rId37"/>
+      <p:regular r:id="rId35"/>
+      <p:bold r:id="rId36"/>
+      <p:italic r:id="rId37"/>
+      <p:boldItalic r:id="rId38"/>
     </p:embeddedFont>
   </p:embeddedFontLst>
   <p:defaultTextStyle>
@@ -289,6 +285,21 @@
     </a:lvl9pPr>
   </p:defaultTextStyle>
 </p:presentation>
+</file>
+
+<file path=ppt/commentAuthors.xml><?xml version="1.0" encoding="utf-8"?>
+<p:cmAuthorLst xmlns:a="http://schemas.openxmlformats.org/drawingml/2006/main" xmlns:r="http://schemas.openxmlformats.org/officeDocument/2006/relationships" xmlns:mc="http://schemas.openxmlformats.org/markup-compatibility/2006" xmlns:mv="urn:schemas-microsoft-com:mac:vml" xmlns:p="http://schemas.openxmlformats.org/presentationml/2006/main" xmlns:c="http://schemas.openxmlformats.org/drawingml/2006/chart" xmlns:dgm="http://schemas.openxmlformats.org/drawingml/2006/diagram" xmlns:o="urn:schemas-microsoft-com:office:office" xmlns:v="urn:schemas-microsoft-com:vml" xmlns:pvml="urn:schemas-microsoft-com:office:powerpoint" xmlns:com="http://schemas.openxmlformats.org/drawingml/2006/compatibility" xmlns:p14="http://schemas.microsoft.com/office/powerpoint/2010/main" xmlns:p15="http://schemas.microsoft.com/office/powerpoint/2012/main" xmlns:ahyp="http://schemas.microsoft.com/office/drawing/2018/hyperlinkcolor">
+  <p:cmAuthor clrIdx="0" id="0" initials="" lastIdx="1" name="Jeanne McClure"/>
+</p:cmAuthorLst>
+</file>
+
+<file path=ppt/comments/comment1.xml><?xml version="1.0" encoding="utf-8"?>
+<p:cmLst xmlns:a="http://schemas.openxmlformats.org/drawingml/2006/main" xmlns:r="http://schemas.openxmlformats.org/officeDocument/2006/relationships" xmlns:mc="http://schemas.openxmlformats.org/markup-compatibility/2006" xmlns:mv="urn:schemas-microsoft-com:mac:vml" xmlns:p="http://schemas.openxmlformats.org/presentationml/2006/main" xmlns:c="http://schemas.openxmlformats.org/drawingml/2006/chart" xmlns:dgm="http://schemas.openxmlformats.org/drawingml/2006/diagram" xmlns:o="urn:schemas-microsoft-com:office:office" xmlns:v="urn:schemas-microsoft-com:vml" xmlns:pvml="urn:schemas-microsoft-com:office:powerpoint" xmlns:com="http://schemas.openxmlformats.org/drawingml/2006/compatibility" xmlns:p14="http://schemas.microsoft.com/office/powerpoint/2010/main" xmlns:p15="http://schemas.microsoft.com/office/powerpoint/2012/main" xmlns:ahyp="http://schemas.microsoft.com/office/drawing/2018/hyperlinkcolor">
+  <p:cm authorId="0" idx="1" dt="2026-04-30T14:36:22.738">
+    <p:pos x="1180" y="2678"/>
+    <p:text>I think we were adding a tool here and then we also need to update the slide before for the tools</p:text>
+  </p:cm>
+</p:cmLst>
 </file>
 
 <file path=ppt/notesMasters/notesMaster1.xml><?xml version="1.0" encoding="utf-8"?>
@@ -5753,7 +5764,7 @@
               <a:buNone/>
             </a:pPr>
             <a:r>
-              <a:rPr b="0" i="1" lang="en-US" sz="2800" u="none" cap="none" strike="noStrike">
+              <a:rPr i="1" lang="en-US" sz="2800">
                 <a:solidFill>
                   <a:srgbClr val="326666"/>
                 </a:solidFill>
@@ -5762,7 +5773,19 @@
                 <a:cs typeface="Spectral"/>
                 <a:sym typeface="Spectral"/>
               </a:rPr>
-              <a:t>Maybe Build · Maybe Demo of an Observable AI System in 90 Minutes</a:t>
+              <a:t xml:space="preserve">Maybe </a:t>
+            </a:r>
+            <a:r>
+              <a:rPr b="0" i="1" lang="en-US" sz="2800" u="none" cap="none" strike="noStrike">
+                <a:solidFill>
+                  <a:srgbClr val="326666"/>
+                </a:solidFill>
+                <a:latin typeface="Spectral"/>
+                <a:ea typeface="Spectral"/>
+                <a:cs typeface="Spectral"/>
+                <a:sym typeface="Spectral"/>
+              </a:rPr>
+              <a:t>Build - Maybe Demo of an Observable AI System in 90 Minutes</a:t>
             </a:r>
             <a:endParaRPr b="0" i="0" sz="2800" u="none" cap="none" strike="noStrike">
               <a:solidFill>
@@ -22210,4546 +22233,6 @@
 </p:sld>
 </file>
 
-<file path=ppt/slides/slide22.xml><?xml version="1.0" encoding="utf-8"?>
-<p:sld xmlns:a="http://schemas.openxmlformats.org/drawingml/2006/main" xmlns:r="http://schemas.openxmlformats.org/officeDocument/2006/relationships" xmlns:mc="http://schemas.openxmlformats.org/markup-compatibility/2006" xmlns:mv="urn:schemas-microsoft-com:mac:vml" xmlns:p="http://schemas.openxmlformats.org/presentationml/2006/main" xmlns:c="http://schemas.openxmlformats.org/drawingml/2006/chart" xmlns:dgm="http://schemas.openxmlformats.org/drawingml/2006/diagram" xmlns:o="urn:schemas-microsoft-com:office:office" xmlns:v="urn:schemas-microsoft-com:vml" xmlns:pvml="urn:schemas-microsoft-com:office:powerpoint" xmlns:com="http://schemas.openxmlformats.org/drawingml/2006/compatibility" xmlns:p14="http://schemas.microsoft.com/office/powerpoint/2010/main" xmlns:p15="http://schemas.microsoft.com/office/powerpoint/2012/main" xmlns:ahyp="http://schemas.microsoft.com/office/drawing/2018/hyperlinkcolor">
-  <p:cSld>
-    <p:bg>
-      <p:bgPr>
-        <a:solidFill>
-          <a:srgbClr val="FFFFFF"/>
-        </a:solidFill>
-      </p:bgPr>
-    </p:bg>
-    <p:spTree>
-      <p:nvGrpSpPr>
-        <p:cNvPr id="235" name="Shape 235"/>
-        <p:cNvGrpSpPr/>
-        <p:nvPr/>
-      </p:nvGrpSpPr>
-      <p:grpSpPr>
-        <a:xfrm>
-          <a:off x="0" y="0"/>
-          <a:ext cx="0" cy="0"/>
-          <a:chOff x="0" y="0"/>
-          <a:chExt cx="0" cy="0"/>
-        </a:xfrm>
-      </p:grpSpPr>
-      <p:sp>
-        <p:nvSpPr>
-          <p:cNvPr id="236" name="Google Shape;236;p11"/>
-          <p:cNvSpPr/>
-          <p:nvPr/>
-        </p:nvSpPr>
-        <p:spPr>
-          <a:xfrm>
-            <a:off x="9265615" y="457200"/>
-            <a:ext cx="2286000" cy="36576"/>
-          </a:xfrm>
-          <a:prstGeom prst="rect">
-            <a:avLst/>
-          </a:prstGeom>
-          <a:solidFill>
-            <a:srgbClr val="326666"/>
-          </a:solidFill>
-          <a:ln cap="flat" cmpd="sng" w="12700">
-            <a:solidFill>
-              <a:srgbClr val="326666"/>
-            </a:solidFill>
-            <a:prstDash val="solid"/>
-            <a:round/>
-            <a:headEnd len="sm" w="sm" type="none"/>
-            <a:tailEnd len="sm" w="sm" type="none"/>
-          </a:ln>
-        </p:spPr>
-        <p:txBody>
-          <a:bodyPr anchorCtr="0" anchor="ctr" bIns="91425" lIns="91425" spcFirstLastPara="1" rIns="91425" wrap="square" tIns="91425">
-            <a:noAutofit/>
-          </a:bodyPr>
-          <a:lstStyle/>
-          <a:p>
-            <a:pPr indent="0" lvl="0" marL="0" rtl="0" algn="l">
-              <a:spcBef>
-                <a:spcPts val="0"/>
-              </a:spcBef>
-              <a:spcAft>
-                <a:spcPts val="0"/>
-              </a:spcAft>
-              <a:buNone/>
-            </a:pPr>
-            <a:r>
-              <a:t/>
-            </a:r>
-            <a:endParaRPr/>
-          </a:p>
-        </p:txBody>
-      </p:sp>
-      <p:sp>
-        <p:nvSpPr>
-          <p:cNvPr id="237" name="Google Shape;237;p11"/>
-          <p:cNvSpPr/>
-          <p:nvPr/>
-        </p:nvSpPr>
-        <p:spPr>
-          <a:xfrm>
-            <a:off x="9265615" y="548640"/>
-            <a:ext cx="2286000" cy="18288"/>
-          </a:xfrm>
-          <a:prstGeom prst="rect">
-            <a:avLst/>
-          </a:prstGeom>
-          <a:solidFill>
-            <a:srgbClr val="326666"/>
-          </a:solidFill>
-          <a:ln cap="flat" cmpd="sng" w="12700">
-            <a:solidFill>
-              <a:srgbClr val="326666"/>
-            </a:solidFill>
-            <a:prstDash val="solid"/>
-            <a:round/>
-            <a:headEnd len="sm" w="sm" type="none"/>
-            <a:tailEnd len="sm" w="sm" type="none"/>
-          </a:ln>
-        </p:spPr>
-        <p:txBody>
-          <a:bodyPr anchorCtr="0" anchor="ctr" bIns="91425" lIns="91425" spcFirstLastPara="1" rIns="91425" wrap="square" tIns="91425">
-            <a:noAutofit/>
-          </a:bodyPr>
-          <a:lstStyle/>
-          <a:p>
-            <a:pPr indent="0" lvl="0" marL="0" rtl="0" algn="l">
-              <a:spcBef>
-                <a:spcPts val="0"/>
-              </a:spcBef>
-              <a:spcAft>
-                <a:spcPts val="0"/>
-              </a:spcAft>
-              <a:buNone/>
-            </a:pPr>
-            <a:r>
-              <a:t/>
-            </a:r>
-            <a:endParaRPr/>
-          </a:p>
-        </p:txBody>
-      </p:sp>
-      <p:sp>
-        <p:nvSpPr>
-          <p:cNvPr id="238" name="Google Shape;238;p11"/>
-          <p:cNvSpPr/>
-          <p:nvPr/>
-        </p:nvSpPr>
-        <p:spPr>
-          <a:xfrm>
-            <a:off x="502920" y="384048"/>
-            <a:ext cx="914400" cy="320040"/>
-          </a:xfrm>
-          <a:prstGeom prst="rect">
-            <a:avLst/>
-          </a:prstGeom>
-          <a:noFill/>
-          <a:ln>
-            <a:noFill/>
-          </a:ln>
-        </p:spPr>
-        <p:txBody>
-          <a:bodyPr anchorCtr="0" anchor="ctr" bIns="0" lIns="0" spcFirstLastPara="1" rIns="0" wrap="square" tIns="0">
-            <a:noAutofit/>
-          </a:bodyPr>
-          <a:lstStyle/>
-          <a:p>
-            <a:pPr indent="0" lvl="0" marL="0" marR="0" rtl="0" algn="l">
-              <a:spcBef>
-                <a:spcPts val="0"/>
-              </a:spcBef>
-              <a:spcAft>
-                <a:spcPts val="0"/>
-              </a:spcAft>
-              <a:buClr>
-                <a:srgbClr val="0D1B2A"/>
-              </a:buClr>
-              <a:buSzPts val="1300"/>
-              <a:buFont typeface="Lato"/>
-              <a:buNone/>
-            </a:pPr>
-            <a:r>
-              <a:rPr b="1" i="0" lang="en-US" sz="1300" u="none" cap="none" strike="noStrike">
-                <a:solidFill>
-                  <a:srgbClr val="0D1B2A"/>
-                </a:solidFill>
-                <a:latin typeface="Lato"/>
-                <a:ea typeface="Lato"/>
-                <a:cs typeface="Lato"/>
-                <a:sym typeface="Lato"/>
-              </a:rPr>
-              <a:t>01</a:t>
-            </a:r>
-            <a:endParaRPr b="0" i="0" sz="1300" u="none" cap="none" strike="noStrike">
-              <a:solidFill>
-                <a:schemeClr val="dk1"/>
-              </a:solidFill>
-              <a:latin typeface="Calibri"/>
-              <a:ea typeface="Calibri"/>
-              <a:cs typeface="Calibri"/>
-              <a:sym typeface="Calibri"/>
-            </a:endParaRPr>
-          </a:p>
-        </p:txBody>
-      </p:sp>
-      <p:sp>
-        <p:nvSpPr>
-          <p:cNvPr id="239" name="Google Shape;239;p11">
-            <a:hlinkClick r:id="rId3"/>
-          </p:cNvPr>
-          <p:cNvSpPr/>
-          <p:nvPr/>
-        </p:nvSpPr>
-        <p:spPr>
-          <a:xfrm>
-            <a:off x="502920" y="6446520"/>
-            <a:ext cx="2743200" cy="274320"/>
-          </a:xfrm>
-          <a:prstGeom prst="rect">
-            <a:avLst/>
-          </a:prstGeom>
-          <a:noFill/>
-          <a:ln>
-            <a:noFill/>
-          </a:ln>
-        </p:spPr>
-        <p:txBody>
-          <a:bodyPr anchorCtr="0" anchor="ctr" bIns="0" lIns="0" spcFirstLastPara="1" rIns="0" wrap="square" tIns="0">
-            <a:noAutofit/>
-          </a:bodyPr>
-          <a:lstStyle/>
-          <a:p>
-            <a:pPr indent="0" lvl="0" marL="0" marR="0" rtl="0" algn="l">
-              <a:spcBef>
-                <a:spcPts val="0"/>
-              </a:spcBef>
-              <a:spcAft>
-                <a:spcPts val="0"/>
-              </a:spcAft>
-              <a:buClr>
-                <a:srgbClr val="595959"/>
-              </a:buClr>
-              <a:buSzPts val="1000"/>
-              <a:buFont typeface="Lato"/>
-              <a:buNone/>
-            </a:pPr>
-            <a:r>
-              <a:rPr b="0" i="0" lang="en-US" sz="1000" u="sng" cap="none" strike="noStrike">
-                <a:solidFill>
-                  <a:schemeClr val="hlink"/>
-                </a:solidFill>
-                <a:latin typeface="Lato"/>
-                <a:ea typeface="Lato"/>
-                <a:cs typeface="Lato"/>
-                <a:sym typeface="Lato"/>
-                <a:hlinkClick r:id="rId4"/>
-              </a:rPr>
-              <a:t>www.arsinnovate.com</a:t>
-            </a:r>
-            <a:endParaRPr b="0" i="0" sz="1000" u="none" cap="none" strike="noStrike">
-              <a:solidFill>
-                <a:schemeClr val="dk1"/>
-              </a:solidFill>
-              <a:latin typeface="Calibri"/>
-              <a:ea typeface="Calibri"/>
-              <a:cs typeface="Calibri"/>
-              <a:sym typeface="Calibri"/>
-            </a:endParaRPr>
-          </a:p>
-        </p:txBody>
-      </p:sp>
-      <p:sp>
-        <p:nvSpPr>
-          <p:cNvPr id="240" name="Google Shape;240;p11"/>
-          <p:cNvSpPr/>
-          <p:nvPr/>
-        </p:nvSpPr>
-        <p:spPr>
-          <a:xfrm>
-            <a:off x="11551615" y="6400800"/>
-            <a:ext cx="365760" cy="274320"/>
-          </a:xfrm>
-          <a:prstGeom prst="rect">
-            <a:avLst/>
-          </a:prstGeom>
-          <a:noFill/>
-          <a:ln>
-            <a:noFill/>
-          </a:ln>
-        </p:spPr>
-        <p:txBody>
-          <a:bodyPr anchorCtr="0" anchor="ctr" bIns="0" lIns="0" spcFirstLastPara="1" rIns="0" wrap="square" tIns="0">
-            <a:noAutofit/>
-          </a:bodyPr>
-          <a:lstStyle/>
-          <a:p>
-            <a:pPr indent="0" lvl="0" marL="0" marR="0" rtl="0" algn="r">
-              <a:spcBef>
-                <a:spcPts val="0"/>
-              </a:spcBef>
-              <a:spcAft>
-                <a:spcPts val="0"/>
-              </a:spcAft>
-              <a:buClr>
-                <a:srgbClr val="595959"/>
-              </a:buClr>
-              <a:buSzPts val="1100"/>
-              <a:buFont typeface="Lato"/>
-              <a:buNone/>
-            </a:pPr>
-            <a:r>
-              <a:rPr b="0" i="0" lang="en-US" sz="1100" u="none" cap="none" strike="noStrike">
-                <a:solidFill>
-                  <a:srgbClr val="595959"/>
-                </a:solidFill>
-                <a:latin typeface="Lato"/>
-                <a:ea typeface="Lato"/>
-                <a:cs typeface="Lato"/>
-                <a:sym typeface="Lato"/>
-              </a:rPr>
-              <a:t>8</a:t>
-            </a:r>
-            <a:endParaRPr b="0" i="0" sz="1100" u="none" cap="none" strike="noStrike">
-              <a:solidFill>
-                <a:schemeClr val="dk1"/>
-              </a:solidFill>
-              <a:latin typeface="Calibri"/>
-              <a:ea typeface="Calibri"/>
-              <a:cs typeface="Calibri"/>
-              <a:sym typeface="Calibri"/>
-            </a:endParaRPr>
-          </a:p>
-        </p:txBody>
-      </p:sp>
-      <p:sp>
-        <p:nvSpPr>
-          <p:cNvPr id="241" name="Google Shape;241;p11"/>
-          <p:cNvSpPr/>
-          <p:nvPr/>
-        </p:nvSpPr>
-        <p:spPr>
-          <a:xfrm>
-            <a:off x="502920" y="960120"/>
-            <a:ext cx="11185855" cy="1097280"/>
-          </a:xfrm>
-          <a:prstGeom prst="rect">
-            <a:avLst/>
-          </a:prstGeom>
-          <a:noFill/>
-          <a:ln>
-            <a:noFill/>
-          </a:ln>
-        </p:spPr>
-        <p:txBody>
-          <a:bodyPr anchorCtr="0" anchor="t" bIns="0" lIns="0" spcFirstLastPara="1" rIns="0" wrap="square" tIns="0">
-            <a:noAutofit/>
-          </a:bodyPr>
-          <a:lstStyle/>
-          <a:p>
-            <a:pPr indent="0" lvl="0" marL="0" marR="0" rtl="0" algn="l">
-              <a:spcBef>
-                <a:spcPts val="0"/>
-              </a:spcBef>
-              <a:spcAft>
-                <a:spcPts val="0"/>
-              </a:spcAft>
-              <a:buClr>
-                <a:srgbClr val="0D1B2A"/>
-              </a:buClr>
-              <a:buSzPts val="4000"/>
-              <a:buFont typeface="Spectral"/>
-              <a:buNone/>
-            </a:pPr>
-            <a:r>
-              <a:rPr b="1" i="0" lang="en-US" sz="4000" u="none" cap="none" strike="noStrike">
-                <a:solidFill>
-                  <a:srgbClr val="0D1B2A"/>
-                </a:solidFill>
-                <a:latin typeface="Spectral"/>
-                <a:ea typeface="Spectral"/>
-                <a:cs typeface="Spectral"/>
-                <a:sym typeface="Spectral"/>
-              </a:rPr>
-              <a:t>Get the repo. Now — while I’m talking.</a:t>
-            </a:r>
-            <a:endParaRPr b="0" i="0" sz="4000" u="none" cap="none" strike="noStrike">
-              <a:solidFill>
-                <a:schemeClr val="dk1"/>
-              </a:solidFill>
-              <a:latin typeface="Calibri"/>
-              <a:ea typeface="Calibri"/>
-              <a:cs typeface="Calibri"/>
-              <a:sym typeface="Calibri"/>
-            </a:endParaRPr>
-          </a:p>
-        </p:txBody>
-      </p:sp>
-      <p:pic>
-        <p:nvPicPr>
-          <p:cNvPr descr="preencoded.png" id="242" name="Google Shape;242;p11"/>
-          <p:cNvPicPr preferRelativeResize="0"/>
-          <p:nvPr/>
-        </p:nvPicPr>
-        <p:blipFill rotWithShape="1">
-          <a:blip r:embed="rId5">
-            <a:alphaModFix/>
-          </a:blip>
-          <a:srcRect b="0" l="0" r="0" t="0"/>
-          <a:stretch/>
-        </p:blipFill>
-        <p:spPr>
-          <a:xfrm>
-            <a:off x="502920" y="2377440"/>
-            <a:ext cx="548640" cy="548640"/>
-          </a:xfrm>
-          <a:prstGeom prst="rect">
-            <a:avLst/>
-          </a:prstGeom>
-          <a:noFill/>
-          <a:ln>
-            <a:noFill/>
-          </a:ln>
-        </p:spPr>
-      </p:pic>
-      <p:sp>
-        <p:nvSpPr>
-          <p:cNvPr id="243" name="Google Shape;243;p11"/>
-          <p:cNvSpPr/>
-          <p:nvPr/>
-        </p:nvSpPr>
-        <p:spPr>
-          <a:xfrm>
-            <a:off x="1234440" y="2331720"/>
-            <a:ext cx="4937760" cy="411480"/>
-          </a:xfrm>
-          <a:prstGeom prst="rect">
-            <a:avLst/>
-          </a:prstGeom>
-          <a:noFill/>
-          <a:ln>
-            <a:noFill/>
-          </a:ln>
-        </p:spPr>
-        <p:txBody>
-          <a:bodyPr anchorCtr="0" anchor="ctr" bIns="0" lIns="0" spcFirstLastPara="1" rIns="0" wrap="square" tIns="0">
-            <a:noAutofit/>
-          </a:bodyPr>
-          <a:lstStyle/>
-          <a:p>
-            <a:pPr indent="0" lvl="0" marL="0" marR="0" rtl="0" algn="l">
-              <a:spcBef>
-                <a:spcPts val="0"/>
-              </a:spcBef>
-              <a:spcAft>
-                <a:spcPts val="0"/>
-              </a:spcAft>
-              <a:buClr>
-                <a:srgbClr val="0D1B2A"/>
-              </a:buClr>
-              <a:buSzPts val="1800"/>
-              <a:buFont typeface="Spectral"/>
-              <a:buNone/>
-            </a:pPr>
-            <a:r>
-              <a:rPr b="1" i="0" lang="en-US" sz="1800" u="none" cap="none" strike="noStrike">
-                <a:solidFill>
-                  <a:srgbClr val="0D1B2A"/>
-                </a:solidFill>
-                <a:latin typeface="Spectral"/>
-                <a:ea typeface="Spectral"/>
-                <a:cs typeface="Spectral"/>
-                <a:sym typeface="Spectral"/>
-              </a:rPr>
-              <a:t>Type one URL</a:t>
-            </a:r>
-            <a:endParaRPr b="0" i="0" sz="1800" u="none" cap="none" strike="noStrike">
-              <a:solidFill>
-                <a:schemeClr val="dk1"/>
-              </a:solidFill>
-              <a:latin typeface="Calibri"/>
-              <a:ea typeface="Calibri"/>
-              <a:cs typeface="Calibri"/>
-              <a:sym typeface="Calibri"/>
-            </a:endParaRPr>
-          </a:p>
-        </p:txBody>
-      </p:sp>
-      <p:sp>
-        <p:nvSpPr>
-          <p:cNvPr id="244" name="Google Shape;244;p11"/>
-          <p:cNvSpPr/>
-          <p:nvPr/>
-        </p:nvSpPr>
-        <p:spPr>
-          <a:xfrm>
-            <a:off x="1234440" y="2788920"/>
-            <a:ext cx="4937760" cy="1280160"/>
-          </a:xfrm>
-          <a:prstGeom prst="rect">
-            <a:avLst/>
-          </a:prstGeom>
-          <a:noFill/>
-          <a:ln>
-            <a:noFill/>
-          </a:ln>
-        </p:spPr>
-        <p:txBody>
-          <a:bodyPr anchorCtr="0" anchor="t" bIns="0" lIns="0" spcFirstLastPara="1" rIns="0" wrap="square" tIns="0">
-            <a:noAutofit/>
-          </a:bodyPr>
-          <a:lstStyle/>
-          <a:p>
-            <a:pPr indent="0" lvl="0" marL="0" marR="0" rtl="0" algn="l">
-              <a:spcBef>
-                <a:spcPts val="0"/>
-              </a:spcBef>
-              <a:spcAft>
-                <a:spcPts val="0"/>
-              </a:spcAft>
-              <a:buClr>
-                <a:srgbClr val="202124"/>
-              </a:buClr>
-              <a:buSzPts val="1200"/>
-              <a:buFont typeface="Lato"/>
-              <a:buNone/>
-            </a:pPr>
-            <a:r>
-              <a:rPr b="0" i="0" lang="en-US" sz="1200" u="none" cap="none" strike="noStrike">
-                <a:solidFill>
-                  <a:srgbClr val="202124"/>
-                </a:solidFill>
-                <a:latin typeface="Lato"/>
-                <a:ea typeface="Lato"/>
-                <a:cs typeface="Lato"/>
-                <a:sym typeface="Lato"/>
-              </a:rPr>
-              <a:t>bit.ly/3ONJiqb</a:t>
-            </a:r>
-            <a:endParaRPr b="0" i="0" sz="1200" u="none" cap="none" strike="noStrike">
-              <a:solidFill>
-                <a:srgbClr val="202124"/>
-              </a:solidFill>
-              <a:latin typeface="Lato"/>
-              <a:ea typeface="Lato"/>
-              <a:cs typeface="Lato"/>
-              <a:sym typeface="Lato"/>
-            </a:endParaRPr>
-          </a:p>
-          <a:p>
-            <a:pPr indent="0" lvl="0" marL="0" marR="0" rtl="0" algn="l">
-              <a:spcBef>
-                <a:spcPts val="0"/>
-              </a:spcBef>
-              <a:spcAft>
-                <a:spcPts val="0"/>
-              </a:spcAft>
-              <a:buClr>
-                <a:srgbClr val="202124"/>
-              </a:buClr>
-              <a:buSzPts val="1200"/>
-              <a:buFont typeface="Lato"/>
-              <a:buNone/>
-            </a:pPr>
-            <a:r>
-              <a:rPr b="0" i="0" lang="en-US" sz="1200" u="none" cap="none" strike="noStrike">
-                <a:solidFill>
-                  <a:srgbClr val="202124"/>
-                </a:solidFill>
-                <a:latin typeface="Lato"/>
-                <a:ea typeface="Lato"/>
-                <a:cs typeface="Lato"/>
-                <a:sym typeface="Lato"/>
-              </a:rPr>
-              <a:t>Redirects to github.com/gigimcc4/DevOpsDays_llmops. Bookmark it now — you’ll come back tonight.</a:t>
-            </a:r>
-            <a:endParaRPr b="0" i="0" sz="1200" u="none" cap="none" strike="noStrike">
-              <a:solidFill>
-                <a:srgbClr val="202124"/>
-              </a:solidFill>
-              <a:latin typeface="Lato"/>
-              <a:ea typeface="Lato"/>
-              <a:cs typeface="Lato"/>
-              <a:sym typeface="Lato"/>
-            </a:endParaRPr>
-          </a:p>
-          <a:p>
-            <a:pPr indent="0" lvl="0" marL="0" marR="0" rtl="0" algn="l">
-              <a:spcBef>
-                <a:spcPts val="0"/>
-              </a:spcBef>
-              <a:spcAft>
-                <a:spcPts val="0"/>
-              </a:spcAft>
-              <a:buClr>
-                <a:srgbClr val="202124"/>
-              </a:buClr>
-              <a:buSzPts val="1200"/>
-              <a:buFont typeface="Lato"/>
-              <a:buNone/>
-            </a:pPr>
-            <a:r>
-              <a:rPr b="0" i="0" lang="en-US" sz="1200" u="none" cap="none" strike="noStrike">
-                <a:solidFill>
-                  <a:srgbClr val="202124"/>
-                </a:solidFill>
-                <a:latin typeface="Lato"/>
-                <a:ea typeface="Lato"/>
-                <a:cs typeface="Lato"/>
-                <a:sym typeface="Lato"/>
-              </a:rPr>
-              <a:t>No git? Same URL, click green Code button, Download ZIP.</a:t>
-            </a:r>
-            <a:endParaRPr b="0" i="0" sz="1200" u="none" cap="none" strike="noStrike">
-              <a:solidFill>
-                <a:schemeClr val="dk1"/>
-              </a:solidFill>
-              <a:latin typeface="Calibri"/>
-              <a:ea typeface="Calibri"/>
-              <a:cs typeface="Calibri"/>
-              <a:sym typeface="Calibri"/>
-            </a:endParaRPr>
-          </a:p>
-        </p:txBody>
-      </p:sp>
-      <p:pic>
-        <p:nvPicPr>
-          <p:cNvPr descr="preencoded.png" id="245" name="Google Shape;245;p11"/>
-          <p:cNvPicPr preferRelativeResize="0"/>
-          <p:nvPr/>
-        </p:nvPicPr>
-        <p:blipFill rotWithShape="1">
-          <a:blip r:embed="rId6">
-            <a:alphaModFix/>
-          </a:blip>
-          <a:srcRect b="0" l="0" r="0" t="0"/>
-          <a:stretch/>
-        </p:blipFill>
-        <p:spPr>
-          <a:xfrm>
-            <a:off x="6217920" y="2377440"/>
-            <a:ext cx="548640" cy="548640"/>
-          </a:xfrm>
-          <a:prstGeom prst="rect">
-            <a:avLst/>
-          </a:prstGeom>
-          <a:noFill/>
-          <a:ln>
-            <a:noFill/>
-          </a:ln>
-        </p:spPr>
-      </p:pic>
-      <p:sp>
-        <p:nvSpPr>
-          <p:cNvPr id="246" name="Google Shape;246;p11"/>
-          <p:cNvSpPr/>
-          <p:nvPr/>
-        </p:nvSpPr>
-        <p:spPr>
-          <a:xfrm>
-            <a:off x="6949440" y="2331720"/>
-            <a:ext cx="4937760" cy="411480"/>
-          </a:xfrm>
-          <a:prstGeom prst="rect">
-            <a:avLst/>
-          </a:prstGeom>
-          <a:noFill/>
-          <a:ln>
-            <a:noFill/>
-          </a:ln>
-        </p:spPr>
-        <p:txBody>
-          <a:bodyPr anchorCtr="0" anchor="ctr" bIns="0" lIns="0" spcFirstLastPara="1" rIns="0" wrap="square" tIns="0">
-            <a:noAutofit/>
-          </a:bodyPr>
-          <a:lstStyle/>
-          <a:p>
-            <a:pPr indent="0" lvl="0" marL="0" marR="0" rtl="0" algn="l">
-              <a:spcBef>
-                <a:spcPts val="0"/>
-              </a:spcBef>
-              <a:spcAft>
-                <a:spcPts val="0"/>
-              </a:spcAft>
-              <a:buClr>
-                <a:srgbClr val="0D1B2A"/>
-              </a:buClr>
-              <a:buSzPts val="1800"/>
-              <a:buFont typeface="Spectral"/>
-              <a:buNone/>
-            </a:pPr>
-            <a:r>
-              <a:rPr b="1" i="0" lang="en-US" sz="1800" u="none" cap="none" strike="noStrike">
-                <a:solidFill>
-                  <a:srgbClr val="0D1B2A"/>
-                </a:solidFill>
-                <a:latin typeface="Spectral"/>
-                <a:ea typeface="Spectral"/>
-                <a:cs typeface="Spectral"/>
-                <a:sym typeface="Spectral"/>
-              </a:rPr>
-              <a:t>Or clone in your terminal</a:t>
-            </a:r>
-            <a:endParaRPr b="0" i="0" sz="1800" u="none" cap="none" strike="noStrike">
-              <a:solidFill>
-                <a:schemeClr val="dk1"/>
-              </a:solidFill>
-              <a:latin typeface="Calibri"/>
-              <a:ea typeface="Calibri"/>
-              <a:cs typeface="Calibri"/>
-              <a:sym typeface="Calibri"/>
-            </a:endParaRPr>
-          </a:p>
-        </p:txBody>
-      </p:sp>
-      <p:sp>
-        <p:nvSpPr>
-          <p:cNvPr id="247" name="Google Shape;247;p11"/>
-          <p:cNvSpPr/>
-          <p:nvPr/>
-        </p:nvSpPr>
-        <p:spPr>
-          <a:xfrm>
-            <a:off x="6949440" y="2788920"/>
-            <a:ext cx="4937760" cy="1280160"/>
-          </a:xfrm>
-          <a:prstGeom prst="rect">
-            <a:avLst/>
-          </a:prstGeom>
-          <a:noFill/>
-          <a:ln>
-            <a:noFill/>
-          </a:ln>
-        </p:spPr>
-        <p:txBody>
-          <a:bodyPr anchorCtr="0" anchor="t" bIns="0" lIns="0" spcFirstLastPara="1" rIns="0" wrap="square" tIns="0">
-            <a:noAutofit/>
-          </a:bodyPr>
-          <a:lstStyle/>
-          <a:p>
-            <a:pPr indent="0" lvl="0" marL="0" marR="0" rtl="0" algn="l">
-              <a:spcBef>
-                <a:spcPts val="0"/>
-              </a:spcBef>
-              <a:spcAft>
-                <a:spcPts val="0"/>
-              </a:spcAft>
-              <a:buClr>
-                <a:srgbClr val="202124"/>
-              </a:buClr>
-              <a:buSzPts val="1200"/>
-              <a:buFont typeface="Lato"/>
-              <a:buNone/>
-            </a:pPr>
-            <a:r>
-              <a:rPr b="0" i="0" lang="en-US" sz="1200" u="none" cap="none" strike="noStrike">
-                <a:solidFill>
-                  <a:srgbClr val="202124"/>
-                </a:solidFill>
-                <a:latin typeface="Lato"/>
-                <a:ea typeface="Lato"/>
-                <a:cs typeface="Lato"/>
-                <a:sym typeface="Lato"/>
-              </a:rPr>
-              <a:t>git clone https://github.com/gigimcc4/DevOpsDays_llmops.git</a:t>
-            </a:r>
-            <a:endParaRPr b="0" i="0" sz="1200" u="none" cap="none" strike="noStrike">
-              <a:solidFill>
-                <a:srgbClr val="202124"/>
-              </a:solidFill>
-              <a:latin typeface="Lato"/>
-              <a:ea typeface="Lato"/>
-              <a:cs typeface="Lato"/>
-              <a:sym typeface="Lato"/>
-            </a:endParaRPr>
-          </a:p>
-          <a:p>
-            <a:pPr indent="0" lvl="0" marL="0" marR="0" rtl="0" algn="l">
-              <a:spcBef>
-                <a:spcPts val="0"/>
-              </a:spcBef>
-              <a:spcAft>
-                <a:spcPts val="0"/>
-              </a:spcAft>
-              <a:buClr>
-                <a:srgbClr val="202124"/>
-              </a:buClr>
-              <a:buSzPts val="1200"/>
-              <a:buFont typeface="Lato"/>
-              <a:buNone/>
-            </a:pPr>
-            <a:r>
-              <a:rPr b="0" i="0" lang="en-US" sz="1200" u="none" cap="none" strike="noStrike">
-                <a:solidFill>
-                  <a:srgbClr val="202124"/>
-                </a:solidFill>
-                <a:latin typeface="Lato"/>
-                <a:ea typeface="Lato"/>
-                <a:cs typeface="Lato"/>
-                <a:sym typeface="Lato"/>
-              </a:rPr>
-              <a:t>Then: cd DevOpsDays_llmops</a:t>
-            </a:r>
-            <a:endParaRPr b="0" i="0" sz="1200" u="none" cap="none" strike="noStrike">
-              <a:solidFill>
-                <a:schemeClr val="dk1"/>
-              </a:solidFill>
-              <a:latin typeface="Calibri"/>
-              <a:ea typeface="Calibri"/>
-              <a:cs typeface="Calibri"/>
-              <a:sym typeface="Calibri"/>
-            </a:endParaRPr>
-          </a:p>
-        </p:txBody>
-      </p:sp>
-      <p:pic>
-        <p:nvPicPr>
-          <p:cNvPr descr="preencoded.png" id="248" name="Google Shape;248;p11"/>
-          <p:cNvPicPr preferRelativeResize="0"/>
-          <p:nvPr/>
-        </p:nvPicPr>
-        <p:blipFill rotWithShape="1">
-          <a:blip r:embed="rId7">
-            <a:alphaModFix/>
-          </a:blip>
-          <a:srcRect b="0" l="0" r="0" t="0"/>
-          <a:stretch/>
-        </p:blipFill>
-        <p:spPr>
-          <a:xfrm>
-            <a:off x="502920" y="4206240"/>
-            <a:ext cx="548640" cy="548640"/>
-          </a:xfrm>
-          <a:prstGeom prst="rect">
-            <a:avLst/>
-          </a:prstGeom>
-          <a:noFill/>
-          <a:ln>
-            <a:noFill/>
-          </a:ln>
-        </p:spPr>
-      </p:pic>
-      <p:sp>
-        <p:nvSpPr>
-          <p:cNvPr id="249" name="Google Shape;249;p11"/>
-          <p:cNvSpPr/>
-          <p:nvPr/>
-        </p:nvSpPr>
-        <p:spPr>
-          <a:xfrm>
-            <a:off x="1234440" y="4160520"/>
-            <a:ext cx="4937760" cy="411480"/>
-          </a:xfrm>
-          <a:prstGeom prst="rect">
-            <a:avLst/>
-          </a:prstGeom>
-          <a:noFill/>
-          <a:ln>
-            <a:noFill/>
-          </a:ln>
-        </p:spPr>
-        <p:txBody>
-          <a:bodyPr anchorCtr="0" anchor="ctr" bIns="0" lIns="0" spcFirstLastPara="1" rIns="0" wrap="square" tIns="0">
-            <a:noAutofit/>
-          </a:bodyPr>
-          <a:lstStyle/>
-          <a:p>
-            <a:pPr indent="0" lvl="0" marL="0" marR="0" rtl="0" algn="l">
-              <a:spcBef>
-                <a:spcPts val="0"/>
-              </a:spcBef>
-              <a:spcAft>
-                <a:spcPts val="0"/>
-              </a:spcAft>
-              <a:buClr>
-                <a:srgbClr val="0D1B2A"/>
-              </a:buClr>
-              <a:buSzPts val="1800"/>
-              <a:buFont typeface="Spectral"/>
-              <a:buNone/>
-            </a:pPr>
-            <a:r>
-              <a:rPr b="1" i="0" lang="en-US" sz="1800" u="none" cap="none" strike="noStrike">
-                <a:solidFill>
-                  <a:srgbClr val="0D1B2A"/>
-                </a:solidFill>
-                <a:latin typeface="Spectral"/>
-                <a:ea typeface="Spectral"/>
-                <a:cs typeface="Spectral"/>
-                <a:sym typeface="Spectral"/>
-              </a:rPr>
-              <a:t>Open it in your IDE</a:t>
-            </a:r>
-            <a:endParaRPr b="0" i="0" sz="1800" u="none" cap="none" strike="noStrike">
-              <a:solidFill>
-                <a:schemeClr val="dk1"/>
-              </a:solidFill>
-              <a:latin typeface="Calibri"/>
-              <a:ea typeface="Calibri"/>
-              <a:cs typeface="Calibri"/>
-              <a:sym typeface="Calibri"/>
-            </a:endParaRPr>
-          </a:p>
-        </p:txBody>
-      </p:sp>
-      <p:sp>
-        <p:nvSpPr>
-          <p:cNvPr id="250" name="Google Shape;250;p11"/>
-          <p:cNvSpPr/>
-          <p:nvPr/>
-        </p:nvSpPr>
-        <p:spPr>
-          <a:xfrm>
-            <a:off x="1234440" y="4617720"/>
-            <a:ext cx="4937760" cy="1280160"/>
-          </a:xfrm>
-          <a:prstGeom prst="rect">
-            <a:avLst/>
-          </a:prstGeom>
-          <a:noFill/>
-          <a:ln>
-            <a:noFill/>
-          </a:ln>
-        </p:spPr>
-        <p:txBody>
-          <a:bodyPr anchorCtr="0" anchor="t" bIns="0" lIns="0" spcFirstLastPara="1" rIns="0" wrap="square" tIns="0">
-            <a:noAutofit/>
-          </a:bodyPr>
-          <a:lstStyle/>
-          <a:p>
-            <a:pPr indent="0" lvl="0" marL="0" marR="0" rtl="0" algn="l">
-              <a:spcBef>
-                <a:spcPts val="0"/>
-              </a:spcBef>
-              <a:spcAft>
-                <a:spcPts val="0"/>
-              </a:spcAft>
-              <a:buClr>
-                <a:srgbClr val="202124"/>
-              </a:buClr>
-              <a:buSzPts val="1200"/>
-              <a:buFont typeface="Lato"/>
-              <a:buNone/>
-            </a:pPr>
-            <a:r>
-              <a:rPr b="0" i="0" lang="en-US" sz="1200" u="none" cap="none" strike="noStrike">
-                <a:solidFill>
-                  <a:srgbClr val="202124"/>
-                </a:solidFill>
-                <a:latin typeface="Lato"/>
-                <a:ea typeface="Lato"/>
-                <a:cs typeface="Lato"/>
-                <a:sym typeface="Lato"/>
-              </a:rPr>
-              <a:t>VS Code, Positron (Jeanne’s pick today), Cursor, PyCharm — whatever you have. You’ll want it open to read each step’s rag.py.</a:t>
-            </a:r>
-            <a:endParaRPr b="0" i="0" sz="1200" u="none" cap="none" strike="noStrike">
-              <a:solidFill>
-                <a:schemeClr val="dk1"/>
-              </a:solidFill>
-              <a:latin typeface="Calibri"/>
-              <a:ea typeface="Calibri"/>
-              <a:cs typeface="Calibri"/>
-              <a:sym typeface="Calibri"/>
-            </a:endParaRPr>
-          </a:p>
-        </p:txBody>
-      </p:sp>
-      <p:pic>
-        <p:nvPicPr>
-          <p:cNvPr descr="preencoded.png" id="251" name="Google Shape;251;p11"/>
-          <p:cNvPicPr preferRelativeResize="0"/>
-          <p:nvPr/>
-        </p:nvPicPr>
-        <p:blipFill rotWithShape="1">
-          <a:blip r:embed="rId8">
-            <a:alphaModFix/>
-          </a:blip>
-          <a:srcRect b="0" l="0" r="0" t="0"/>
-          <a:stretch/>
-        </p:blipFill>
-        <p:spPr>
-          <a:xfrm>
-            <a:off x="6217920" y="4206240"/>
-            <a:ext cx="548640" cy="548640"/>
-          </a:xfrm>
-          <a:prstGeom prst="rect">
-            <a:avLst/>
-          </a:prstGeom>
-          <a:noFill/>
-          <a:ln>
-            <a:noFill/>
-          </a:ln>
-        </p:spPr>
-      </p:pic>
-      <p:sp>
-        <p:nvSpPr>
-          <p:cNvPr id="252" name="Google Shape;252;p11"/>
-          <p:cNvSpPr/>
-          <p:nvPr/>
-        </p:nvSpPr>
-        <p:spPr>
-          <a:xfrm>
-            <a:off x="6949440" y="4160520"/>
-            <a:ext cx="4937760" cy="411480"/>
-          </a:xfrm>
-          <a:prstGeom prst="rect">
-            <a:avLst/>
-          </a:prstGeom>
-          <a:noFill/>
-          <a:ln>
-            <a:noFill/>
-          </a:ln>
-        </p:spPr>
-        <p:txBody>
-          <a:bodyPr anchorCtr="0" anchor="ctr" bIns="0" lIns="0" spcFirstLastPara="1" rIns="0" wrap="square" tIns="0">
-            <a:noAutofit/>
-          </a:bodyPr>
-          <a:lstStyle/>
-          <a:p>
-            <a:pPr indent="0" lvl="0" marL="0" marR="0" rtl="0" algn="l">
-              <a:spcBef>
-                <a:spcPts val="0"/>
-              </a:spcBef>
-              <a:spcAft>
-                <a:spcPts val="0"/>
-              </a:spcAft>
-              <a:buClr>
-                <a:srgbClr val="0D1B2A"/>
-              </a:buClr>
-              <a:buSzPts val="1800"/>
-              <a:buFont typeface="Spectral"/>
-              <a:buNone/>
-            </a:pPr>
-            <a:r>
-              <a:rPr b="1" i="0" lang="en-US" sz="1800" u="none" cap="none" strike="noStrike">
-                <a:solidFill>
-                  <a:srgbClr val="0D1B2A"/>
-                </a:solidFill>
-                <a:latin typeface="Spectral"/>
-                <a:ea typeface="Spectral"/>
-                <a:cs typeface="Spectral"/>
-                <a:sym typeface="Spectral"/>
-              </a:rPr>
-              <a:t>Company laptop locked down?</a:t>
-            </a:r>
-            <a:endParaRPr b="0" i="0" sz="1800" u="none" cap="none" strike="noStrike">
-              <a:solidFill>
-                <a:schemeClr val="dk1"/>
-              </a:solidFill>
-              <a:latin typeface="Calibri"/>
-              <a:ea typeface="Calibri"/>
-              <a:cs typeface="Calibri"/>
-              <a:sym typeface="Calibri"/>
-            </a:endParaRPr>
-          </a:p>
-        </p:txBody>
-      </p:sp>
-      <p:sp>
-        <p:nvSpPr>
-          <p:cNvPr id="253" name="Google Shape;253;p11"/>
-          <p:cNvSpPr/>
-          <p:nvPr/>
-        </p:nvSpPr>
-        <p:spPr>
-          <a:xfrm>
-            <a:off x="6949440" y="4617720"/>
-            <a:ext cx="4937760" cy="1280160"/>
-          </a:xfrm>
-          <a:prstGeom prst="rect">
-            <a:avLst/>
-          </a:prstGeom>
-          <a:noFill/>
-          <a:ln>
-            <a:noFill/>
-          </a:ln>
-        </p:spPr>
-        <p:txBody>
-          <a:bodyPr anchorCtr="0" anchor="t" bIns="0" lIns="0" spcFirstLastPara="1" rIns="0" wrap="square" tIns="0">
-            <a:noAutofit/>
-          </a:bodyPr>
-          <a:lstStyle/>
-          <a:p>
-            <a:pPr indent="0" lvl="0" marL="0" marR="0" rtl="0" algn="l">
-              <a:spcBef>
-                <a:spcPts val="0"/>
-              </a:spcBef>
-              <a:spcAft>
-                <a:spcPts val="0"/>
-              </a:spcAft>
-              <a:buClr>
-                <a:srgbClr val="202124"/>
-              </a:buClr>
-              <a:buSzPts val="1200"/>
-              <a:buFont typeface="Lato"/>
-              <a:buNone/>
-            </a:pPr>
-            <a:r>
-              <a:rPr b="0" i="0" lang="en-US" sz="1200" u="none" cap="none" strike="noStrike">
-                <a:solidFill>
-                  <a:srgbClr val="202124"/>
-                </a:solidFill>
-                <a:latin typeface="Lato"/>
-                <a:ea typeface="Lato"/>
-                <a:cs typeface="Lato"/>
-                <a:sym typeface="Lato"/>
-              </a:rPr>
-              <a:t>Get the URL anyway. Run it on a personal machine tonight. You leave with the repo either way.</a:t>
-            </a:r>
-            <a:endParaRPr b="0" i="0" sz="1200" u="none" cap="none" strike="noStrike">
-              <a:solidFill>
-                <a:schemeClr val="dk1"/>
-              </a:solidFill>
-              <a:latin typeface="Calibri"/>
-              <a:ea typeface="Calibri"/>
-              <a:cs typeface="Calibri"/>
-              <a:sym typeface="Calibri"/>
-            </a:endParaRPr>
-          </a:p>
-        </p:txBody>
-      </p:sp>
-      <p:pic>
-        <p:nvPicPr>
-          <p:cNvPr id="254" name="Google Shape;254;p11" title="Gemini_Generated_Image_rbdzoirbdzoirbdz.png"/>
-          <p:cNvPicPr preferRelativeResize="0"/>
-          <p:nvPr/>
-        </p:nvPicPr>
-        <p:blipFill rotWithShape="1">
-          <a:blip r:embed="rId9">
-            <a:alphaModFix/>
-          </a:blip>
-          <a:srcRect b="33061" l="22742" r="28149" t="10923"/>
-          <a:stretch/>
-        </p:blipFill>
-        <p:spPr>
-          <a:xfrm>
-            <a:off x="9885440" y="6291673"/>
-            <a:ext cx="1727432" cy="492600"/>
-          </a:xfrm>
-          <a:prstGeom prst="rect">
-            <a:avLst/>
-          </a:prstGeom>
-          <a:noFill/>
-          <a:ln>
-            <a:noFill/>
-          </a:ln>
-        </p:spPr>
-      </p:pic>
-    </p:spTree>
-  </p:cSld>
-  <p:clrMapOvr>
-    <a:masterClrMapping/>
-  </p:clrMapOvr>
-</p:sld>
-</file>
-
-<file path=ppt/slides/slide23.xml><?xml version="1.0" encoding="utf-8"?>
-<p:sld xmlns:a="http://schemas.openxmlformats.org/drawingml/2006/main" xmlns:r="http://schemas.openxmlformats.org/officeDocument/2006/relationships" xmlns:mc="http://schemas.openxmlformats.org/markup-compatibility/2006" xmlns:mv="urn:schemas-microsoft-com:mac:vml" xmlns:p="http://schemas.openxmlformats.org/presentationml/2006/main" xmlns:c="http://schemas.openxmlformats.org/drawingml/2006/chart" xmlns:dgm="http://schemas.openxmlformats.org/drawingml/2006/diagram" xmlns:o="urn:schemas-microsoft-com:office:office" xmlns:v="urn:schemas-microsoft-com:vml" xmlns:pvml="urn:schemas-microsoft-com:office:powerpoint" xmlns:com="http://schemas.openxmlformats.org/drawingml/2006/compatibility" xmlns:p14="http://schemas.microsoft.com/office/powerpoint/2010/main" xmlns:p15="http://schemas.microsoft.com/office/powerpoint/2012/main" xmlns:ahyp="http://schemas.microsoft.com/office/drawing/2018/hyperlinkcolor">
-  <p:cSld>
-    <p:bg>
-      <p:bgPr>
-        <a:solidFill>
-          <a:srgbClr val="FFFFFF"/>
-        </a:solidFill>
-      </p:bgPr>
-    </p:bg>
-    <p:spTree>
-      <p:nvGrpSpPr>
-        <p:cNvPr id="235" name="Shape 235"/>
-        <p:cNvGrpSpPr/>
-        <p:nvPr/>
-      </p:nvGrpSpPr>
-      <p:grpSpPr>
-        <a:xfrm>
-          <a:off x="0" y="0"/>
-          <a:ext cx="0" cy="0"/>
-          <a:chOff x="0" y="0"/>
-          <a:chExt cx="0" cy="0"/>
-        </a:xfrm>
-      </p:grpSpPr>
-      <p:sp>
-        <p:nvSpPr>
-          <p:cNvPr id="236" name="Google Shape;236;p11"/>
-          <p:cNvSpPr/>
-          <p:nvPr/>
-        </p:nvSpPr>
-        <p:spPr>
-          <a:xfrm>
-            <a:off x="9265615" y="457200"/>
-            <a:ext cx="2286000" cy="36576"/>
-          </a:xfrm>
-          <a:prstGeom prst="rect">
-            <a:avLst/>
-          </a:prstGeom>
-          <a:solidFill>
-            <a:srgbClr val="326666"/>
-          </a:solidFill>
-          <a:ln cap="flat" cmpd="sng" w="12700">
-            <a:solidFill>
-              <a:srgbClr val="326666"/>
-            </a:solidFill>
-            <a:prstDash val="solid"/>
-            <a:round/>
-            <a:headEnd len="sm" w="sm" type="none"/>
-            <a:tailEnd len="sm" w="sm" type="none"/>
-          </a:ln>
-        </p:spPr>
-        <p:txBody>
-          <a:bodyPr anchorCtr="0" anchor="ctr" bIns="91425" lIns="91425" spcFirstLastPara="1" rIns="91425" wrap="square" tIns="91425">
-            <a:noAutofit/>
-          </a:bodyPr>
-          <a:lstStyle/>
-          <a:p>
-            <a:pPr indent="0" lvl="0" marL="0" rtl="0" algn="l">
-              <a:spcBef>
-                <a:spcPts val="0"/>
-              </a:spcBef>
-              <a:spcAft>
-                <a:spcPts val="0"/>
-              </a:spcAft>
-              <a:buNone/>
-            </a:pPr>
-            <a:r>
-              <a:t/>
-            </a:r>
-            <a:endParaRPr/>
-          </a:p>
-        </p:txBody>
-      </p:sp>
-      <p:sp>
-        <p:nvSpPr>
-          <p:cNvPr id="237" name="Google Shape;237;p11"/>
-          <p:cNvSpPr/>
-          <p:nvPr/>
-        </p:nvSpPr>
-        <p:spPr>
-          <a:xfrm>
-            <a:off x="9265615" y="548640"/>
-            <a:ext cx="2286000" cy="18288"/>
-          </a:xfrm>
-          <a:prstGeom prst="rect">
-            <a:avLst/>
-          </a:prstGeom>
-          <a:solidFill>
-            <a:srgbClr val="326666"/>
-          </a:solidFill>
-          <a:ln cap="flat" cmpd="sng" w="12700">
-            <a:solidFill>
-              <a:srgbClr val="326666"/>
-            </a:solidFill>
-            <a:prstDash val="solid"/>
-            <a:round/>
-            <a:headEnd len="sm" w="sm" type="none"/>
-            <a:tailEnd len="sm" w="sm" type="none"/>
-          </a:ln>
-        </p:spPr>
-        <p:txBody>
-          <a:bodyPr anchorCtr="0" anchor="ctr" bIns="91425" lIns="91425" spcFirstLastPara="1" rIns="91425" wrap="square" tIns="91425">
-            <a:noAutofit/>
-          </a:bodyPr>
-          <a:lstStyle/>
-          <a:p>
-            <a:pPr indent="0" lvl="0" marL="0" rtl="0" algn="l">
-              <a:spcBef>
-                <a:spcPts val="0"/>
-              </a:spcBef>
-              <a:spcAft>
-                <a:spcPts val="0"/>
-              </a:spcAft>
-              <a:buNone/>
-            </a:pPr>
-            <a:r>
-              <a:t/>
-            </a:r>
-            <a:endParaRPr/>
-          </a:p>
-        </p:txBody>
-      </p:sp>
-      <p:sp>
-        <p:nvSpPr>
-          <p:cNvPr id="238" name="Google Shape;238;p11"/>
-          <p:cNvSpPr/>
-          <p:nvPr/>
-        </p:nvSpPr>
-        <p:spPr>
-          <a:xfrm>
-            <a:off x="502920" y="384048"/>
-            <a:ext cx="914400" cy="320040"/>
-          </a:xfrm>
-          <a:prstGeom prst="rect">
-            <a:avLst/>
-          </a:prstGeom>
-          <a:noFill/>
-          <a:ln>
-            <a:noFill/>
-          </a:ln>
-        </p:spPr>
-        <p:txBody>
-          <a:bodyPr anchorCtr="0" anchor="ctr" bIns="0" lIns="0" spcFirstLastPara="1" rIns="0" wrap="square" tIns="0">
-            <a:noAutofit/>
-          </a:bodyPr>
-          <a:lstStyle/>
-          <a:p>
-            <a:pPr indent="0" lvl="0" marL="0" marR="0" rtl="0" algn="l">
-              <a:spcBef>
-                <a:spcPts val="0"/>
-              </a:spcBef>
-              <a:spcAft>
-                <a:spcPts val="0"/>
-              </a:spcAft>
-              <a:buClr>
-                <a:srgbClr val="0D1B2A"/>
-              </a:buClr>
-              <a:buSzPts val="1300"/>
-              <a:buFont typeface="Lato"/>
-              <a:buNone/>
-            </a:pPr>
-            <a:r>
-              <a:rPr b="1" i="0" lang="en-US" sz="1300" u="none" cap="none" strike="noStrike">
-                <a:solidFill>
-                  <a:srgbClr val="0D1B2A"/>
-                </a:solidFill>
-                <a:latin typeface="Lato"/>
-                <a:ea typeface="Lato"/>
-                <a:cs typeface="Lato"/>
-                <a:sym typeface="Lato"/>
-              </a:rPr>
-              <a:t>01</a:t>
-            </a:r>
-            <a:endParaRPr b="0" i="0" sz="1300" u="none" cap="none" strike="noStrike">
-              <a:solidFill>
-                <a:schemeClr val="dk1"/>
-              </a:solidFill>
-              <a:latin typeface="Calibri"/>
-              <a:ea typeface="Calibri"/>
-              <a:cs typeface="Calibri"/>
-              <a:sym typeface="Calibri"/>
-            </a:endParaRPr>
-          </a:p>
-        </p:txBody>
-      </p:sp>
-      <p:sp>
-        <p:nvSpPr>
-          <p:cNvPr id="239" name="Google Shape;239;p11">
-            <a:hlinkClick r:id="rId3"/>
-          </p:cNvPr>
-          <p:cNvSpPr/>
-          <p:nvPr/>
-        </p:nvSpPr>
-        <p:spPr>
-          <a:xfrm>
-            <a:off x="502920" y="6446520"/>
-            <a:ext cx="2743200" cy="274320"/>
-          </a:xfrm>
-          <a:prstGeom prst="rect">
-            <a:avLst/>
-          </a:prstGeom>
-          <a:noFill/>
-          <a:ln>
-            <a:noFill/>
-          </a:ln>
-        </p:spPr>
-        <p:txBody>
-          <a:bodyPr anchorCtr="0" anchor="ctr" bIns="0" lIns="0" spcFirstLastPara="1" rIns="0" wrap="square" tIns="0">
-            <a:noAutofit/>
-          </a:bodyPr>
-          <a:lstStyle/>
-          <a:p>
-            <a:pPr indent="0" lvl="0" marL="0" marR="0" rtl="0" algn="l">
-              <a:spcBef>
-                <a:spcPts val="0"/>
-              </a:spcBef>
-              <a:spcAft>
-                <a:spcPts val="0"/>
-              </a:spcAft>
-              <a:buClr>
-                <a:srgbClr val="595959"/>
-              </a:buClr>
-              <a:buSzPts val="1000"/>
-              <a:buFont typeface="Lato"/>
-              <a:buNone/>
-            </a:pPr>
-            <a:r>
-              <a:rPr b="0" i="0" lang="en-US" sz="1000" u="sng" cap="none" strike="noStrike">
-                <a:solidFill>
-                  <a:schemeClr val="hlink"/>
-                </a:solidFill>
-                <a:latin typeface="Lato"/>
-                <a:ea typeface="Lato"/>
-                <a:cs typeface="Lato"/>
-                <a:sym typeface="Lato"/>
-                <a:hlinkClick r:id="rId4"/>
-              </a:rPr>
-              <a:t>www.arsinnovate.com</a:t>
-            </a:r>
-            <a:endParaRPr b="0" i="0" sz="1000" u="none" cap="none" strike="noStrike">
-              <a:solidFill>
-                <a:schemeClr val="dk1"/>
-              </a:solidFill>
-              <a:latin typeface="Calibri"/>
-              <a:ea typeface="Calibri"/>
-              <a:cs typeface="Calibri"/>
-              <a:sym typeface="Calibri"/>
-            </a:endParaRPr>
-          </a:p>
-        </p:txBody>
-      </p:sp>
-      <p:sp>
-        <p:nvSpPr>
-          <p:cNvPr id="240" name="Google Shape;240;p11"/>
-          <p:cNvSpPr/>
-          <p:nvPr/>
-        </p:nvSpPr>
-        <p:spPr>
-          <a:xfrm>
-            <a:off x="11551615" y="6400800"/>
-            <a:ext cx="365760" cy="274320"/>
-          </a:xfrm>
-          <a:prstGeom prst="rect">
-            <a:avLst/>
-          </a:prstGeom>
-          <a:noFill/>
-          <a:ln>
-            <a:noFill/>
-          </a:ln>
-        </p:spPr>
-        <p:txBody>
-          <a:bodyPr anchorCtr="0" anchor="ctr" bIns="0" lIns="0" spcFirstLastPara="1" rIns="0" wrap="square" tIns="0">
-            <a:noAutofit/>
-          </a:bodyPr>
-          <a:lstStyle/>
-          <a:p>
-            <a:pPr indent="0" lvl="0" marL="0" marR="0" rtl="0" algn="r">
-              <a:spcBef>
-                <a:spcPts val="0"/>
-              </a:spcBef>
-              <a:spcAft>
-                <a:spcPts val="0"/>
-              </a:spcAft>
-              <a:buClr>
-                <a:srgbClr val="595959"/>
-              </a:buClr>
-              <a:buSzPts val="1100"/>
-              <a:buFont typeface="Lato"/>
-              <a:buNone/>
-            </a:pPr>
-            <a:r>
-              <a:rPr b="0" i="0" lang="en-US" sz="1100" u="none" cap="none" strike="noStrike">
-                <a:solidFill>
-                  <a:srgbClr val="595959"/>
-                </a:solidFill>
-                <a:latin typeface="Lato"/>
-                <a:ea typeface="Lato"/>
-                <a:cs typeface="Lato"/>
-                <a:sym typeface="Lato"/>
-              </a:rPr>
-              <a:t>8</a:t>
-            </a:r>
-            <a:endParaRPr b="0" i="0" sz="1100" u="none" cap="none" strike="noStrike">
-              <a:solidFill>
-                <a:schemeClr val="dk1"/>
-              </a:solidFill>
-              <a:latin typeface="Calibri"/>
-              <a:ea typeface="Calibri"/>
-              <a:cs typeface="Calibri"/>
-              <a:sym typeface="Calibri"/>
-            </a:endParaRPr>
-          </a:p>
-        </p:txBody>
-      </p:sp>
-      <p:sp>
-        <p:nvSpPr>
-          <p:cNvPr id="241" name="Google Shape;241;p11"/>
-          <p:cNvSpPr/>
-          <p:nvPr/>
-        </p:nvSpPr>
-        <p:spPr>
-          <a:xfrm>
-            <a:off x="502920" y="960120"/>
-            <a:ext cx="11185855" cy="1097280"/>
-          </a:xfrm>
-          <a:prstGeom prst="rect">
-            <a:avLst/>
-          </a:prstGeom>
-          <a:noFill/>
-          <a:ln>
-            <a:noFill/>
-          </a:ln>
-        </p:spPr>
-        <p:txBody>
-          <a:bodyPr anchorCtr="0" anchor="t" bIns="0" lIns="0" spcFirstLastPara="1" rIns="0" wrap="square" tIns="0">
-            <a:noAutofit/>
-          </a:bodyPr>
-          <a:lstStyle/>
-          <a:p>
-            <a:pPr indent="0" lvl="0" marL="0" marR="0" rtl="0" algn="l">
-              <a:spcBef>
-                <a:spcPts val="0"/>
-              </a:spcBef>
-              <a:spcAft>
-                <a:spcPts val="0"/>
-              </a:spcAft>
-              <a:buClr>
-                <a:srgbClr val="0D1B2A"/>
-              </a:buClr>
-              <a:buSzPts val="4000"/>
-              <a:buFont typeface="Spectral"/>
-              <a:buNone/>
-            </a:pPr>
-            <a:r>
-              <a:rPr b="1" i="0" lang="en-US" sz="4000" u="none" cap="none" strike="noStrike">
-                <a:solidFill>
-                  <a:srgbClr val="0D1B2A"/>
-                </a:solidFill>
-                <a:latin typeface="Spectral"/>
-                <a:ea typeface="Spectral"/>
-                <a:cs typeface="Spectral"/>
-                <a:sym typeface="Spectral"/>
-              </a:rPr>
-              <a:t>One command. Six things installed.</a:t>
-            </a:r>
-            <a:endParaRPr b="0" i="0" sz="4000" u="none" cap="none" strike="noStrike">
-              <a:solidFill>
-                <a:schemeClr val="dk1"/>
-              </a:solidFill>
-              <a:latin typeface="Calibri"/>
-              <a:ea typeface="Calibri"/>
-              <a:cs typeface="Calibri"/>
-              <a:sym typeface="Calibri"/>
-            </a:endParaRPr>
-          </a:p>
-        </p:txBody>
-      </p:sp>
-      <p:pic>
-        <p:nvPicPr>
-          <p:cNvPr descr="preencoded.png" id="242" name="Google Shape;242;p11"/>
-          <p:cNvPicPr preferRelativeResize="0"/>
-          <p:nvPr/>
-        </p:nvPicPr>
-        <p:blipFill rotWithShape="1">
-          <a:blip r:embed="rId5">
-            <a:alphaModFix/>
-          </a:blip>
-          <a:srcRect b="0" l="0" r="0" t="0"/>
-          <a:stretch/>
-        </p:blipFill>
-        <p:spPr>
-          <a:xfrm>
-            <a:off x="502920" y="2377440"/>
-            <a:ext cx="548640" cy="548640"/>
-          </a:xfrm>
-          <a:prstGeom prst="rect">
-            <a:avLst/>
-          </a:prstGeom>
-          <a:noFill/>
-          <a:ln>
-            <a:noFill/>
-          </a:ln>
-        </p:spPr>
-      </p:pic>
-      <p:sp>
-        <p:nvSpPr>
-          <p:cNvPr id="243" name="Google Shape;243;p11"/>
-          <p:cNvSpPr/>
-          <p:nvPr/>
-        </p:nvSpPr>
-        <p:spPr>
-          <a:xfrm>
-            <a:off x="1234440" y="2331720"/>
-            <a:ext cx="4937760" cy="411480"/>
-          </a:xfrm>
-          <a:prstGeom prst="rect">
-            <a:avLst/>
-          </a:prstGeom>
-          <a:noFill/>
-          <a:ln>
-            <a:noFill/>
-          </a:ln>
-        </p:spPr>
-        <p:txBody>
-          <a:bodyPr anchorCtr="0" anchor="ctr" bIns="0" lIns="0" spcFirstLastPara="1" rIns="0" wrap="square" tIns="0">
-            <a:noAutofit/>
-          </a:bodyPr>
-          <a:lstStyle/>
-          <a:p>
-            <a:pPr indent="0" lvl="0" marL="0" marR="0" rtl="0" algn="l">
-              <a:spcBef>
-                <a:spcPts val="0"/>
-              </a:spcBef>
-              <a:spcAft>
-                <a:spcPts val="0"/>
-              </a:spcAft>
-              <a:buClr>
-                <a:srgbClr val="0D1B2A"/>
-              </a:buClr>
-              <a:buSzPts val="1800"/>
-              <a:buFont typeface="Spectral"/>
-              <a:buNone/>
-            </a:pPr>
-            <a:r>
-              <a:rPr b="1" i="0" lang="en-US" sz="1800" u="none" cap="none" strike="noStrike">
-                <a:solidFill>
-                  <a:srgbClr val="0D1B2A"/>
-                </a:solidFill>
-                <a:latin typeface="Spectral"/>
-                <a:ea typeface="Spectral"/>
-                <a:cs typeface="Spectral"/>
-                <a:sym typeface="Spectral"/>
-              </a:rPr>
-              <a:t>One command, two minutes (after Docker is up)</a:t>
-            </a:r>
-            <a:endParaRPr b="0" i="0" sz="1800" u="none" cap="none" strike="noStrike">
-              <a:solidFill>
-                <a:schemeClr val="dk1"/>
-              </a:solidFill>
-              <a:latin typeface="Calibri"/>
-              <a:ea typeface="Calibri"/>
-              <a:cs typeface="Calibri"/>
-              <a:sym typeface="Calibri"/>
-            </a:endParaRPr>
-          </a:p>
-        </p:txBody>
-      </p:sp>
-      <p:sp>
-        <p:nvSpPr>
-          <p:cNvPr id="244" name="Google Shape;244;p11"/>
-          <p:cNvSpPr/>
-          <p:nvPr/>
-        </p:nvSpPr>
-        <p:spPr>
-          <a:xfrm>
-            <a:off x="1234440" y="2788920"/>
-            <a:ext cx="4937760" cy="1280160"/>
-          </a:xfrm>
-          <a:prstGeom prst="rect">
-            <a:avLst/>
-          </a:prstGeom>
-          <a:noFill/>
-          <a:ln>
-            <a:noFill/>
-          </a:ln>
-        </p:spPr>
-        <p:txBody>
-          <a:bodyPr anchorCtr="0" anchor="t" bIns="0" lIns="0" spcFirstLastPara="1" rIns="0" wrap="square" tIns="0">
-            <a:noAutofit/>
-          </a:bodyPr>
-          <a:lstStyle/>
-          <a:p>
-            <a:pPr indent="0" lvl="0" marL="0" marR="0" rtl="0" algn="l">
-              <a:spcBef>
-                <a:spcPts val="0"/>
-              </a:spcBef>
-              <a:spcAft>
-                <a:spcPts val="0"/>
-              </a:spcAft>
-              <a:buClr>
-                <a:srgbClr val="202124"/>
-              </a:buClr>
-              <a:buSzPts val="1200"/>
-              <a:buFont typeface="Lato"/>
-              <a:buNone/>
-            </a:pPr>
-            <a:r>
-              <a:rPr b="0" i="0" lang="en-US" sz="1200" u="none" cap="none" strike="noStrike">
-                <a:solidFill>
-                  <a:srgbClr val="202124"/>
-                </a:solidFill>
-                <a:latin typeface="Lato"/>
-                <a:ea typeface="Lato"/>
-                <a:cs typeface="Lato"/>
-                <a:sym typeface="Lato"/>
-              </a:rPr>
-              <a:t>Run it</a:t>
-            </a:r>
-            <a:endParaRPr b="0" i="0" sz="1200" u="none" cap="none" strike="noStrike">
-              <a:solidFill>
-                <a:srgbClr val="202124"/>
-              </a:solidFill>
-              <a:latin typeface="Lato"/>
-              <a:ea typeface="Lato"/>
-              <a:cs typeface="Lato"/>
-              <a:sym typeface="Lato"/>
-            </a:endParaRPr>
-          </a:p>
-          <a:p>
-            <a:pPr indent="0" lvl="0" marL="0" marR="0" rtl="0" algn="l">
-              <a:spcBef>
-                <a:spcPts val="0"/>
-              </a:spcBef>
-              <a:spcAft>
-                <a:spcPts val="0"/>
-              </a:spcAft>
-              <a:buClr>
-                <a:srgbClr val="202124"/>
-              </a:buClr>
-              <a:buSzPts val="1200"/>
-              <a:buFont typeface="Lato"/>
-              <a:buNone/>
-            </a:pPr>
-            <a:r>
-              <a:rPr b="0" i="0" lang="en-US" sz="1200" u="none" cap="none" strike="noStrike">
-                <a:solidFill>
-                  <a:srgbClr val="202124"/>
-                </a:solidFill>
-                <a:latin typeface="Lato"/>
-                <a:ea typeface="Lato"/>
-                <a:cs typeface="Lato"/>
-                <a:sym typeface="Lato"/>
-              </a:rPr>
-              <a:t>chmod +x setup.sh &amp;&amp; ./setup.sh</a:t>
-            </a:r>
-            <a:endParaRPr b="0" i="0" sz="1200" u="none" cap="none" strike="noStrike">
-              <a:solidFill>
-                <a:srgbClr val="202124"/>
-              </a:solidFill>
-              <a:latin typeface="Lato"/>
-              <a:ea typeface="Lato"/>
-              <a:cs typeface="Lato"/>
-              <a:sym typeface="Lato"/>
-            </a:endParaRPr>
-          </a:p>
-          <a:p>
-            <a:pPr indent="0" lvl="0" marL="0" marR="0" rtl="0" algn="l">
-              <a:spcBef>
-                <a:spcPts val="0"/>
-              </a:spcBef>
-              <a:spcAft>
-                <a:spcPts val="0"/>
-              </a:spcAft>
-              <a:buClr>
-                <a:srgbClr val="202124"/>
-              </a:buClr>
-              <a:buSzPts val="1200"/>
-              <a:buFont typeface="Lato"/>
-              <a:buNone/>
-            </a:pPr>
-            <a:r>
-              <a:rPr b="0" i="0" lang="en-US" sz="1200" u="none" cap="none" strike="noStrike">
-                <a:solidFill>
-                  <a:srgbClr val="202124"/>
-                </a:solidFill>
-                <a:latin typeface="Lato"/>
-                <a:ea typeface="Lato"/>
-                <a:cs typeface="Lato"/>
-                <a:sym typeface="Lato"/>
-              </a:rPr>
-              <a:t>Mac/Linux/WSL only. Re-run anytime — idempotent.</a:t>
-            </a:r>
-            <a:endParaRPr b="0" i="0" sz="1200" u="none" cap="none" strike="noStrike">
-              <a:solidFill>
-                <a:schemeClr val="dk1"/>
-              </a:solidFill>
-              <a:latin typeface="Calibri"/>
-              <a:ea typeface="Calibri"/>
-              <a:cs typeface="Calibri"/>
-              <a:sym typeface="Calibri"/>
-            </a:endParaRPr>
-          </a:p>
-        </p:txBody>
-      </p:sp>
-      <p:pic>
-        <p:nvPicPr>
-          <p:cNvPr descr="preencoded.png" id="245" name="Google Shape;245;p11"/>
-          <p:cNvPicPr preferRelativeResize="0"/>
-          <p:nvPr/>
-        </p:nvPicPr>
-        <p:blipFill rotWithShape="1">
-          <a:blip r:embed="rId6">
-            <a:alphaModFix/>
-          </a:blip>
-          <a:srcRect b="0" l="0" r="0" t="0"/>
-          <a:stretch/>
-        </p:blipFill>
-        <p:spPr>
-          <a:xfrm>
-            <a:off x="6217920" y="2377440"/>
-            <a:ext cx="548640" cy="548640"/>
-          </a:xfrm>
-          <a:prstGeom prst="rect">
-            <a:avLst/>
-          </a:prstGeom>
-          <a:noFill/>
-          <a:ln>
-            <a:noFill/>
-          </a:ln>
-        </p:spPr>
-      </p:pic>
-      <p:sp>
-        <p:nvSpPr>
-          <p:cNvPr id="246" name="Google Shape;246;p11"/>
-          <p:cNvSpPr/>
-          <p:nvPr/>
-        </p:nvSpPr>
-        <p:spPr>
-          <a:xfrm>
-            <a:off x="6949440" y="2331720"/>
-            <a:ext cx="4937760" cy="411480"/>
-          </a:xfrm>
-          <a:prstGeom prst="rect">
-            <a:avLst/>
-          </a:prstGeom>
-          <a:noFill/>
-          <a:ln>
-            <a:noFill/>
-          </a:ln>
-        </p:spPr>
-        <p:txBody>
-          <a:bodyPr anchorCtr="0" anchor="ctr" bIns="0" lIns="0" spcFirstLastPara="1" rIns="0" wrap="square" tIns="0">
-            <a:noAutofit/>
-          </a:bodyPr>
-          <a:lstStyle/>
-          <a:p>
-            <a:pPr indent="0" lvl="0" marL="0" marR="0" rtl="0" algn="l">
-              <a:spcBef>
-                <a:spcPts val="0"/>
-              </a:spcBef>
-              <a:spcAft>
-                <a:spcPts val="0"/>
-              </a:spcAft>
-              <a:buClr>
-                <a:srgbClr val="0D1B2A"/>
-              </a:buClr>
-              <a:buSzPts val="1800"/>
-              <a:buFont typeface="Spectral"/>
-              <a:buNone/>
-            </a:pPr>
-            <a:r>
-              <a:rPr b="1" i="0" lang="en-US" sz="1800" u="none" cap="none" strike="noStrike">
-                <a:solidFill>
-                  <a:srgbClr val="0D1B2A"/>
-                </a:solidFill>
-                <a:latin typeface="Spectral"/>
-                <a:ea typeface="Spectral"/>
-                <a:cs typeface="Spectral"/>
-                <a:sym typeface="Spectral"/>
-              </a:rPr>
-              <a:t>What setup.sh installs</a:t>
-            </a:r>
-            <a:endParaRPr b="0" i="0" sz="1800" u="none" cap="none" strike="noStrike">
-              <a:solidFill>
-                <a:schemeClr val="dk1"/>
-              </a:solidFill>
-              <a:latin typeface="Calibri"/>
-              <a:ea typeface="Calibri"/>
-              <a:cs typeface="Calibri"/>
-              <a:sym typeface="Calibri"/>
-            </a:endParaRPr>
-          </a:p>
-        </p:txBody>
-      </p:sp>
-      <p:sp>
-        <p:nvSpPr>
-          <p:cNvPr id="247" name="Google Shape;247;p11"/>
-          <p:cNvSpPr/>
-          <p:nvPr/>
-        </p:nvSpPr>
-        <p:spPr>
-          <a:xfrm>
-            <a:off x="6949440" y="2788920"/>
-            <a:ext cx="4937760" cy="1280160"/>
-          </a:xfrm>
-          <a:prstGeom prst="rect">
-            <a:avLst/>
-          </a:prstGeom>
-          <a:noFill/>
-          <a:ln>
-            <a:noFill/>
-          </a:ln>
-        </p:spPr>
-        <p:txBody>
-          <a:bodyPr anchorCtr="0" anchor="t" bIns="0" lIns="0" spcFirstLastPara="1" rIns="0" wrap="square" tIns="0">
-            <a:noAutofit/>
-          </a:bodyPr>
-          <a:lstStyle/>
-          <a:p>
-            <a:pPr indent="0" lvl="0" marL="0" marR="0" rtl="0" algn="l">
-              <a:spcBef>
-                <a:spcPts val="0"/>
-              </a:spcBef>
-              <a:spcAft>
-                <a:spcPts val="0"/>
-              </a:spcAft>
-              <a:buClr>
-                <a:srgbClr val="202124"/>
-              </a:buClr>
-              <a:buSzPts val="1200"/>
-              <a:buFont typeface="Lato"/>
-              <a:buNone/>
-            </a:pPr>
-            <a:r>
-              <a:rPr b="0" i="0" lang="en-US" sz="1200" u="none" cap="none" strike="noStrike">
-                <a:solidFill>
-                  <a:srgbClr val="202124"/>
-                </a:solidFill>
-                <a:latin typeface="Lato"/>
-                <a:ea typeface="Lato"/>
-                <a:cs typeface="Lato"/>
-                <a:sym typeface="Lato"/>
-              </a:rPr>
-              <a:t>Ollama + 1.5 GB of models · Python packages · Langfuse (Docker) · Jaeger (Docker)</a:t>
-            </a:r>
-            <a:endParaRPr b="0" i="0" sz="1200" u="none" cap="none" strike="noStrike">
-              <a:solidFill>
-                <a:srgbClr val="202124"/>
-              </a:solidFill>
-              <a:latin typeface="Lato"/>
-              <a:ea typeface="Lato"/>
-              <a:cs typeface="Lato"/>
-              <a:sym typeface="Lato"/>
-            </a:endParaRPr>
-          </a:p>
-          <a:p>
-            <a:pPr indent="0" lvl="0" marL="0" marR="0" rtl="0" algn="l">
-              <a:spcBef>
-                <a:spcPts val="0"/>
-              </a:spcBef>
-              <a:spcAft>
-                <a:spcPts val="0"/>
-              </a:spcAft>
-              <a:buClr>
-                <a:srgbClr val="202124"/>
-              </a:buClr>
-              <a:buSzPts val="1200"/>
-              <a:buFont typeface="Lato"/>
-              <a:buNone/>
-            </a:pPr>
-            <a:r>
-              <a:rPr b="0" i="0" lang="en-US" sz="1200" u="none" cap="none" strike="noStrike">
-                <a:solidFill>
-                  <a:srgbClr val="202124"/>
-                </a:solidFill>
-                <a:latin typeface="Lato"/>
-                <a:ea typeface="Lato"/>
-                <a:cs typeface="Lato"/>
-                <a:sym typeface="Lato"/>
-              </a:rPr>
-              <a:t>First run: 5–8 min. Second run: seconds.</a:t>
-            </a:r>
-            <a:endParaRPr b="0" i="0" sz="1200" u="none" cap="none" strike="noStrike">
-              <a:solidFill>
-                <a:schemeClr val="dk1"/>
-              </a:solidFill>
-              <a:latin typeface="Calibri"/>
-              <a:ea typeface="Calibri"/>
-              <a:cs typeface="Calibri"/>
-              <a:sym typeface="Calibri"/>
-            </a:endParaRPr>
-          </a:p>
-        </p:txBody>
-      </p:sp>
-      <p:pic>
-        <p:nvPicPr>
-          <p:cNvPr descr="preencoded.png" id="248" name="Google Shape;248;p11"/>
-          <p:cNvPicPr preferRelativeResize="0"/>
-          <p:nvPr/>
-        </p:nvPicPr>
-        <p:blipFill rotWithShape="1">
-          <a:blip r:embed="rId7">
-            <a:alphaModFix/>
-          </a:blip>
-          <a:srcRect b="0" l="0" r="0" t="0"/>
-          <a:stretch/>
-        </p:blipFill>
-        <p:spPr>
-          <a:xfrm>
-            <a:off x="502920" y="4206240"/>
-            <a:ext cx="548640" cy="548640"/>
-          </a:xfrm>
-          <a:prstGeom prst="rect">
-            <a:avLst/>
-          </a:prstGeom>
-          <a:noFill/>
-          <a:ln>
-            <a:noFill/>
-          </a:ln>
-        </p:spPr>
-      </p:pic>
-      <p:sp>
-        <p:nvSpPr>
-          <p:cNvPr id="249" name="Google Shape;249;p11"/>
-          <p:cNvSpPr/>
-          <p:nvPr/>
-        </p:nvSpPr>
-        <p:spPr>
-          <a:xfrm>
-            <a:off x="1234440" y="4160520"/>
-            <a:ext cx="4937760" cy="411480"/>
-          </a:xfrm>
-          <a:prstGeom prst="rect">
-            <a:avLst/>
-          </a:prstGeom>
-          <a:noFill/>
-          <a:ln>
-            <a:noFill/>
-          </a:ln>
-        </p:spPr>
-        <p:txBody>
-          <a:bodyPr anchorCtr="0" anchor="ctr" bIns="0" lIns="0" spcFirstLastPara="1" rIns="0" wrap="square" tIns="0">
-            <a:noAutofit/>
-          </a:bodyPr>
-          <a:lstStyle/>
-          <a:p>
-            <a:pPr indent="0" lvl="0" marL="0" marR="0" rtl="0" algn="l">
-              <a:spcBef>
-                <a:spcPts val="0"/>
-              </a:spcBef>
-              <a:spcAft>
-                <a:spcPts val="0"/>
-              </a:spcAft>
-              <a:buClr>
-                <a:srgbClr val="0D1B2A"/>
-              </a:buClr>
-              <a:buSzPts val="1800"/>
-              <a:buFont typeface="Spectral"/>
-              <a:buNone/>
-            </a:pPr>
-            <a:r>
-              <a:rPr b="1" i="0" lang="en-US" sz="1800" u="none" cap="none" strike="noStrike">
-                <a:solidFill>
-                  <a:srgbClr val="0D1B2A"/>
-                </a:solidFill>
-                <a:latin typeface="Spectral"/>
-                <a:ea typeface="Spectral"/>
-                <a:cs typeface="Spectral"/>
-                <a:sym typeface="Spectral"/>
-              </a:rPr>
-              <a:t>What it WON’T install</a:t>
-            </a:r>
-            <a:endParaRPr b="0" i="0" sz="1800" u="none" cap="none" strike="noStrike">
-              <a:solidFill>
-                <a:schemeClr val="dk1"/>
-              </a:solidFill>
-              <a:latin typeface="Calibri"/>
-              <a:ea typeface="Calibri"/>
-              <a:cs typeface="Calibri"/>
-              <a:sym typeface="Calibri"/>
-            </a:endParaRPr>
-          </a:p>
-        </p:txBody>
-      </p:sp>
-      <p:sp>
-        <p:nvSpPr>
-          <p:cNvPr id="250" name="Google Shape;250;p11"/>
-          <p:cNvSpPr/>
-          <p:nvPr/>
-        </p:nvSpPr>
-        <p:spPr>
-          <a:xfrm>
-            <a:off x="1234440" y="4617720"/>
-            <a:ext cx="4937760" cy="1280160"/>
-          </a:xfrm>
-          <a:prstGeom prst="rect">
-            <a:avLst/>
-          </a:prstGeom>
-          <a:noFill/>
-          <a:ln>
-            <a:noFill/>
-          </a:ln>
-        </p:spPr>
-        <p:txBody>
-          <a:bodyPr anchorCtr="0" anchor="t" bIns="0" lIns="0" spcFirstLastPara="1" rIns="0" wrap="square" tIns="0">
-            <a:noAutofit/>
-          </a:bodyPr>
-          <a:lstStyle/>
-          <a:p>
-            <a:pPr indent="0" lvl="0" marL="0" marR="0" rtl="0" algn="l">
-              <a:spcBef>
-                <a:spcPts val="0"/>
-              </a:spcBef>
-              <a:spcAft>
-                <a:spcPts val="0"/>
-              </a:spcAft>
-              <a:buClr>
-                <a:srgbClr val="202124"/>
-              </a:buClr>
-              <a:buSzPts val="1200"/>
-              <a:buFont typeface="Lato"/>
-              <a:buNone/>
-            </a:pPr>
-            <a:r>
-              <a:rPr b="0" i="0" lang="en-US" sz="1200" u="none" cap="none" strike="noStrike">
-                <a:solidFill>
-                  <a:srgbClr val="202124"/>
-                </a:solidFill>
-                <a:latin typeface="Lato"/>
-                <a:ea typeface="Lato"/>
-                <a:cs typeface="Lato"/>
-                <a:sym typeface="Lato"/>
-              </a:rPr>
-              <a:t>Python 3.10+ and Docker Desktop. Don’t have those? You’re a demo-watcher today.</a:t>
-            </a:r>
-            <a:endParaRPr b="0" i="0" sz="1200" u="none" cap="none" strike="noStrike">
-              <a:solidFill>
-                <a:schemeClr val="dk1"/>
-              </a:solidFill>
-              <a:latin typeface="Calibri"/>
-              <a:ea typeface="Calibri"/>
-              <a:cs typeface="Calibri"/>
-              <a:sym typeface="Calibri"/>
-            </a:endParaRPr>
-          </a:p>
-        </p:txBody>
-      </p:sp>
-      <p:pic>
-        <p:nvPicPr>
-          <p:cNvPr descr="preencoded.png" id="251" name="Google Shape;251;p11"/>
-          <p:cNvPicPr preferRelativeResize="0"/>
-          <p:nvPr/>
-        </p:nvPicPr>
-        <p:blipFill rotWithShape="1">
-          <a:blip r:embed="rId8">
-            <a:alphaModFix/>
-          </a:blip>
-          <a:srcRect b="0" l="0" r="0" t="0"/>
-          <a:stretch/>
-        </p:blipFill>
-        <p:spPr>
-          <a:xfrm>
-            <a:off x="6217920" y="4206240"/>
-            <a:ext cx="548640" cy="548640"/>
-          </a:xfrm>
-          <a:prstGeom prst="rect">
-            <a:avLst/>
-          </a:prstGeom>
-          <a:noFill/>
-          <a:ln>
-            <a:noFill/>
-          </a:ln>
-        </p:spPr>
-      </p:pic>
-      <p:sp>
-        <p:nvSpPr>
-          <p:cNvPr id="252" name="Google Shape;252;p11"/>
-          <p:cNvSpPr/>
-          <p:nvPr/>
-        </p:nvSpPr>
-        <p:spPr>
-          <a:xfrm>
-            <a:off x="6949440" y="4160520"/>
-            <a:ext cx="4937760" cy="411480"/>
-          </a:xfrm>
-          <a:prstGeom prst="rect">
-            <a:avLst/>
-          </a:prstGeom>
-          <a:noFill/>
-          <a:ln>
-            <a:noFill/>
-          </a:ln>
-        </p:spPr>
-        <p:txBody>
-          <a:bodyPr anchorCtr="0" anchor="ctr" bIns="0" lIns="0" spcFirstLastPara="1" rIns="0" wrap="square" tIns="0">
-            <a:noAutofit/>
-          </a:bodyPr>
-          <a:lstStyle/>
-          <a:p>
-            <a:pPr indent="0" lvl="0" marL="0" marR="0" rtl="0" algn="l">
-              <a:spcBef>
-                <a:spcPts val="0"/>
-              </a:spcBef>
-              <a:spcAft>
-                <a:spcPts val="0"/>
-              </a:spcAft>
-              <a:buClr>
-                <a:srgbClr val="0D1B2A"/>
-              </a:buClr>
-              <a:buSzPts val="1800"/>
-              <a:buFont typeface="Spectral"/>
-              <a:buNone/>
-            </a:pPr>
-            <a:r>
-              <a:rPr b="1" i="0" lang="en-US" sz="1800" u="none" cap="none" strike="noStrike">
-                <a:solidFill>
-                  <a:srgbClr val="0D1B2A"/>
-                </a:solidFill>
-                <a:latin typeface="Spectral"/>
-                <a:ea typeface="Spectral"/>
-                <a:cs typeface="Spectral"/>
-                <a:sym typeface="Spectral"/>
-              </a:rPr>
-              <a:t>Success looks like</a:t>
-            </a:r>
-            <a:endParaRPr b="0" i="0" sz="1800" u="none" cap="none" strike="noStrike">
-              <a:solidFill>
-                <a:schemeClr val="dk1"/>
-              </a:solidFill>
-              <a:latin typeface="Calibri"/>
-              <a:ea typeface="Calibri"/>
-              <a:cs typeface="Calibri"/>
-              <a:sym typeface="Calibri"/>
-            </a:endParaRPr>
-          </a:p>
-        </p:txBody>
-      </p:sp>
-      <p:sp>
-        <p:nvSpPr>
-          <p:cNvPr id="253" name="Google Shape;253;p11"/>
-          <p:cNvSpPr/>
-          <p:nvPr/>
-        </p:nvSpPr>
-        <p:spPr>
-          <a:xfrm>
-            <a:off x="6949440" y="4617720"/>
-            <a:ext cx="4937760" cy="1280160"/>
-          </a:xfrm>
-          <a:prstGeom prst="rect">
-            <a:avLst/>
-          </a:prstGeom>
-          <a:noFill/>
-          <a:ln>
-            <a:noFill/>
-          </a:ln>
-        </p:spPr>
-        <p:txBody>
-          <a:bodyPr anchorCtr="0" anchor="t" bIns="0" lIns="0" spcFirstLastPara="1" rIns="0" wrap="square" tIns="0">
-            <a:noAutofit/>
-          </a:bodyPr>
-          <a:lstStyle/>
-          <a:p>
-            <a:pPr indent="0" lvl="0" marL="0" marR="0" rtl="0" algn="l">
-              <a:spcBef>
-                <a:spcPts val="0"/>
-              </a:spcBef>
-              <a:spcAft>
-                <a:spcPts val="0"/>
-              </a:spcAft>
-              <a:buClr>
-                <a:srgbClr val="202124"/>
-              </a:buClr>
-              <a:buSzPts val="1200"/>
-              <a:buFont typeface="Lato"/>
-              <a:buNone/>
-            </a:pPr>
-            <a:r>
-              <a:rPr b="0" i="0" lang="en-US" sz="1200" u="none" cap="none" strike="noStrike">
-                <a:solidFill>
-                  <a:srgbClr val="202124"/>
-                </a:solidFill>
-                <a:latin typeface="Lato"/>
-                <a:ea typeface="Lato"/>
-                <a:cs typeface="Lato"/>
-                <a:sym typeface="Lato"/>
-              </a:rPr>
-              <a:t>Langfuse at localhost:3000 · Jaeger at localhost:16686 · check_env.py all green.</a:t>
-            </a:r>
-            <a:endParaRPr b="0" i="0" sz="1200" u="none" cap="none" strike="noStrike">
-              <a:solidFill>
-                <a:schemeClr val="dk1"/>
-              </a:solidFill>
-              <a:latin typeface="Calibri"/>
-              <a:ea typeface="Calibri"/>
-              <a:cs typeface="Calibri"/>
-              <a:sym typeface="Calibri"/>
-            </a:endParaRPr>
-          </a:p>
-        </p:txBody>
-      </p:sp>
-      <p:pic>
-        <p:nvPicPr>
-          <p:cNvPr id="254" name="Google Shape;254;p11" title="Gemini_Generated_Image_rbdzoirbdzoirbdz.png"/>
-          <p:cNvPicPr preferRelativeResize="0"/>
-          <p:nvPr/>
-        </p:nvPicPr>
-        <p:blipFill rotWithShape="1">
-          <a:blip r:embed="rId9">
-            <a:alphaModFix/>
-          </a:blip>
-          <a:srcRect b="33061" l="22742" r="28149" t="10923"/>
-          <a:stretch/>
-        </p:blipFill>
-        <p:spPr>
-          <a:xfrm>
-            <a:off x="9885440" y="6291673"/>
-            <a:ext cx="1727432" cy="492600"/>
-          </a:xfrm>
-          <a:prstGeom prst="rect">
-            <a:avLst/>
-          </a:prstGeom>
-          <a:noFill/>
-          <a:ln>
-            <a:noFill/>
-          </a:ln>
-        </p:spPr>
-      </p:pic>
-    </p:spTree>
-  </p:cSld>
-  <p:clrMapOvr>
-    <a:masterClrMapping/>
-  </p:clrMapOvr>
-</p:sld>
-</file>
-
-<file path=ppt/slides/slide24.xml><?xml version="1.0" encoding="utf-8"?>
-<p:sld xmlns:a="http://schemas.openxmlformats.org/drawingml/2006/main" xmlns:r="http://schemas.openxmlformats.org/officeDocument/2006/relationships" xmlns:mc="http://schemas.openxmlformats.org/markup-compatibility/2006" xmlns:mv="urn:schemas-microsoft-com:mac:vml" xmlns:p="http://schemas.openxmlformats.org/presentationml/2006/main" xmlns:c="http://schemas.openxmlformats.org/drawingml/2006/chart" xmlns:dgm="http://schemas.openxmlformats.org/drawingml/2006/diagram" xmlns:o="urn:schemas-microsoft-com:office:office" xmlns:v="urn:schemas-microsoft-com:vml" xmlns:pvml="urn:schemas-microsoft-com:office:powerpoint" xmlns:com="http://schemas.openxmlformats.org/drawingml/2006/compatibility" xmlns:p14="http://schemas.microsoft.com/office/powerpoint/2010/main" xmlns:p15="http://schemas.microsoft.com/office/powerpoint/2012/main" xmlns:ahyp="http://schemas.microsoft.com/office/drawing/2018/hyperlinkcolor">
-  <p:cSld>
-    <p:bg>
-      <p:bgPr>
-        <a:solidFill>
-          <a:srgbClr val="FFFFFF"/>
-        </a:solidFill>
-      </p:bgPr>
-    </p:bg>
-    <p:spTree>
-      <p:nvGrpSpPr>
-        <p:cNvPr id="235" name="Shape 235"/>
-        <p:cNvGrpSpPr/>
-        <p:nvPr/>
-      </p:nvGrpSpPr>
-      <p:grpSpPr>
-        <a:xfrm>
-          <a:off x="0" y="0"/>
-          <a:ext cx="0" cy="0"/>
-          <a:chOff x="0" y="0"/>
-          <a:chExt cx="0" cy="0"/>
-        </a:xfrm>
-      </p:grpSpPr>
-      <p:sp>
-        <p:nvSpPr>
-          <p:cNvPr id="236" name="Google Shape;236;p11"/>
-          <p:cNvSpPr/>
-          <p:nvPr/>
-        </p:nvSpPr>
-        <p:spPr>
-          <a:xfrm>
-            <a:off x="9265615" y="457200"/>
-            <a:ext cx="2286000" cy="36576"/>
-          </a:xfrm>
-          <a:prstGeom prst="rect">
-            <a:avLst/>
-          </a:prstGeom>
-          <a:solidFill>
-            <a:srgbClr val="326666"/>
-          </a:solidFill>
-          <a:ln cap="flat" cmpd="sng" w="12700">
-            <a:solidFill>
-              <a:srgbClr val="326666"/>
-            </a:solidFill>
-            <a:prstDash val="solid"/>
-            <a:round/>
-            <a:headEnd len="sm" w="sm" type="none"/>
-            <a:tailEnd len="sm" w="sm" type="none"/>
-          </a:ln>
-        </p:spPr>
-        <p:txBody>
-          <a:bodyPr anchorCtr="0" anchor="ctr" bIns="91425" lIns="91425" spcFirstLastPara="1" rIns="91425" wrap="square" tIns="91425">
-            <a:noAutofit/>
-          </a:bodyPr>
-          <a:lstStyle/>
-          <a:p>
-            <a:pPr indent="0" lvl="0" marL="0" rtl="0" algn="l">
-              <a:spcBef>
-                <a:spcPts val="0"/>
-              </a:spcBef>
-              <a:spcAft>
-                <a:spcPts val="0"/>
-              </a:spcAft>
-              <a:buNone/>
-            </a:pPr>
-            <a:r>
-              <a:t/>
-            </a:r>
-            <a:endParaRPr/>
-          </a:p>
-        </p:txBody>
-      </p:sp>
-      <p:sp>
-        <p:nvSpPr>
-          <p:cNvPr id="237" name="Google Shape;237;p11"/>
-          <p:cNvSpPr/>
-          <p:nvPr/>
-        </p:nvSpPr>
-        <p:spPr>
-          <a:xfrm>
-            <a:off x="9265615" y="548640"/>
-            <a:ext cx="2286000" cy="18288"/>
-          </a:xfrm>
-          <a:prstGeom prst="rect">
-            <a:avLst/>
-          </a:prstGeom>
-          <a:solidFill>
-            <a:srgbClr val="326666"/>
-          </a:solidFill>
-          <a:ln cap="flat" cmpd="sng" w="12700">
-            <a:solidFill>
-              <a:srgbClr val="326666"/>
-            </a:solidFill>
-            <a:prstDash val="solid"/>
-            <a:round/>
-            <a:headEnd len="sm" w="sm" type="none"/>
-            <a:tailEnd len="sm" w="sm" type="none"/>
-          </a:ln>
-        </p:spPr>
-        <p:txBody>
-          <a:bodyPr anchorCtr="0" anchor="ctr" bIns="91425" lIns="91425" spcFirstLastPara="1" rIns="91425" wrap="square" tIns="91425">
-            <a:noAutofit/>
-          </a:bodyPr>
-          <a:lstStyle/>
-          <a:p>
-            <a:pPr indent="0" lvl="0" marL="0" rtl="0" algn="l">
-              <a:spcBef>
-                <a:spcPts val="0"/>
-              </a:spcBef>
-              <a:spcAft>
-                <a:spcPts val="0"/>
-              </a:spcAft>
-              <a:buNone/>
-            </a:pPr>
-            <a:r>
-              <a:t/>
-            </a:r>
-            <a:endParaRPr/>
-          </a:p>
-        </p:txBody>
-      </p:sp>
-      <p:sp>
-        <p:nvSpPr>
-          <p:cNvPr id="238" name="Google Shape;238;p11"/>
-          <p:cNvSpPr/>
-          <p:nvPr/>
-        </p:nvSpPr>
-        <p:spPr>
-          <a:xfrm>
-            <a:off x="502920" y="384048"/>
-            <a:ext cx="914400" cy="320040"/>
-          </a:xfrm>
-          <a:prstGeom prst="rect">
-            <a:avLst/>
-          </a:prstGeom>
-          <a:noFill/>
-          <a:ln>
-            <a:noFill/>
-          </a:ln>
-        </p:spPr>
-        <p:txBody>
-          <a:bodyPr anchorCtr="0" anchor="ctr" bIns="0" lIns="0" spcFirstLastPara="1" rIns="0" wrap="square" tIns="0">
-            <a:noAutofit/>
-          </a:bodyPr>
-          <a:lstStyle/>
-          <a:p>
-            <a:pPr indent="0" lvl="0" marL="0" marR="0" rtl="0" algn="l">
-              <a:spcBef>
-                <a:spcPts val="0"/>
-              </a:spcBef>
-              <a:spcAft>
-                <a:spcPts val="0"/>
-              </a:spcAft>
-              <a:buClr>
-                <a:srgbClr val="0D1B2A"/>
-              </a:buClr>
-              <a:buSzPts val="1300"/>
-              <a:buFont typeface="Lato"/>
-              <a:buNone/>
-            </a:pPr>
-            <a:r>
-              <a:rPr b="1" i="0" lang="en-US" sz="1300" u="none" cap="none" strike="noStrike">
-                <a:solidFill>
-                  <a:srgbClr val="0D1B2A"/>
-                </a:solidFill>
-                <a:latin typeface="Lato"/>
-                <a:ea typeface="Lato"/>
-                <a:cs typeface="Lato"/>
-                <a:sym typeface="Lato"/>
-              </a:rPr>
-              <a:t>01</a:t>
-            </a:r>
-            <a:endParaRPr b="0" i="0" sz="1300" u="none" cap="none" strike="noStrike">
-              <a:solidFill>
-                <a:schemeClr val="dk1"/>
-              </a:solidFill>
-              <a:latin typeface="Calibri"/>
-              <a:ea typeface="Calibri"/>
-              <a:cs typeface="Calibri"/>
-              <a:sym typeface="Calibri"/>
-            </a:endParaRPr>
-          </a:p>
-        </p:txBody>
-      </p:sp>
-      <p:sp>
-        <p:nvSpPr>
-          <p:cNvPr id="239" name="Google Shape;239;p11">
-            <a:hlinkClick r:id="rId3"/>
-          </p:cNvPr>
-          <p:cNvSpPr/>
-          <p:nvPr/>
-        </p:nvSpPr>
-        <p:spPr>
-          <a:xfrm>
-            <a:off x="502920" y="6446520"/>
-            <a:ext cx="2743200" cy="274320"/>
-          </a:xfrm>
-          <a:prstGeom prst="rect">
-            <a:avLst/>
-          </a:prstGeom>
-          <a:noFill/>
-          <a:ln>
-            <a:noFill/>
-          </a:ln>
-        </p:spPr>
-        <p:txBody>
-          <a:bodyPr anchorCtr="0" anchor="ctr" bIns="0" lIns="0" spcFirstLastPara="1" rIns="0" wrap="square" tIns="0">
-            <a:noAutofit/>
-          </a:bodyPr>
-          <a:lstStyle/>
-          <a:p>
-            <a:pPr indent="0" lvl="0" marL="0" marR="0" rtl="0" algn="l">
-              <a:spcBef>
-                <a:spcPts val="0"/>
-              </a:spcBef>
-              <a:spcAft>
-                <a:spcPts val="0"/>
-              </a:spcAft>
-              <a:buClr>
-                <a:srgbClr val="595959"/>
-              </a:buClr>
-              <a:buSzPts val="1000"/>
-              <a:buFont typeface="Lato"/>
-              <a:buNone/>
-            </a:pPr>
-            <a:r>
-              <a:rPr b="0" i="0" lang="en-US" sz="1000" u="sng" cap="none" strike="noStrike">
-                <a:solidFill>
-                  <a:schemeClr val="hlink"/>
-                </a:solidFill>
-                <a:latin typeface="Lato"/>
-                <a:ea typeface="Lato"/>
-                <a:cs typeface="Lato"/>
-                <a:sym typeface="Lato"/>
-                <a:hlinkClick r:id="rId4"/>
-              </a:rPr>
-              <a:t>www.arsinnovate.com</a:t>
-            </a:r>
-            <a:endParaRPr b="0" i="0" sz="1000" u="none" cap="none" strike="noStrike">
-              <a:solidFill>
-                <a:schemeClr val="dk1"/>
-              </a:solidFill>
-              <a:latin typeface="Calibri"/>
-              <a:ea typeface="Calibri"/>
-              <a:cs typeface="Calibri"/>
-              <a:sym typeface="Calibri"/>
-            </a:endParaRPr>
-          </a:p>
-        </p:txBody>
-      </p:sp>
-      <p:sp>
-        <p:nvSpPr>
-          <p:cNvPr id="240" name="Google Shape;240;p11"/>
-          <p:cNvSpPr/>
-          <p:nvPr/>
-        </p:nvSpPr>
-        <p:spPr>
-          <a:xfrm>
-            <a:off x="11551615" y="6400800"/>
-            <a:ext cx="365760" cy="274320"/>
-          </a:xfrm>
-          <a:prstGeom prst="rect">
-            <a:avLst/>
-          </a:prstGeom>
-          <a:noFill/>
-          <a:ln>
-            <a:noFill/>
-          </a:ln>
-        </p:spPr>
-        <p:txBody>
-          <a:bodyPr anchorCtr="0" anchor="ctr" bIns="0" lIns="0" spcFirstLastPara="1" rIns="0" wrap="square" tIns="0">
-            <a:noAutofit/>
-          </a:bodyPr>
-          <a:lstStyle/>
-          <a:p>
-            <a:pPr indent="0" lvl="0" marL="0" marR="0" rtl="0" algn="r">
-              <a:spcBef>
-                <a:spcPts val="0"/>
-              </a:spcBef>
-              <a:spcAft>
-                <a:spcPts val="0"/>
-              </a:spcAft>
-              <a:buClr>
-                <a:srgbClr val="595959"/>
-              </a:buClr>
-              <a:buSzPts val="1100"/>
-              <a:buFont typeface="Lato"/>
-              <a:buNone/>
-            </a:pPr>
-            <a:r>
-              <a:rPr b="0" i="0" lang="en-US" sz="1100" u="none" cap="none" strike="noStrike">
-                <a:solidFill>
-                  <a:srgbClr val="595959"/>
-                </a:solidFill>
-                <a:latin typeface="Lato"/>
-                <a:ea typeface="Lato"/>
-                <a:cs typeface="Lato"/>
-                <a:sym typeface="Lato"/>
-              </a:rPr>
-              <a:t>8</a:t>
-            </a:r>
-            <a:endParaRPr b="0" i="0" sz="1100" u="none" cap="none" strike="noStrike">
-              <a:solidFill>
-                <a:schemeClr val="dk1"/>
-              </a:solidFill>
-              <a:latin typeface="Calibri"/>
-              <a:ea typeface="Calibri"/>
-              <a:cs typeface="Calibri"/>
-              <a:sym typeface="Calibri"/>
-            </a:endParaRPr>
-          </a:p>
-        </p:txBody>
-      </p:sp>
-      <p:sp>
-        <p:nvSpPr>
-          <p:cNvPr id="241" name="Google Shape;241;p11"/>
-          <p:cNvSpPr/>
-          <p:nvPr/>
-        </p:nvSpPr>
-        <p:spPr>
-          <a:xfrm>
-            <a:off x="502920" y="960120"/>
-            <a:ext cx="11185855" cy="1097280"/>
-          </a:xfrm>
-          <a:prstGeom prst="rect">
-            <a:avLst/>
-          </a:prstGeom>
-          <a:noFill/>
-          <a:ln>
-            <a:noFill/>
-          </a:ln>
-        </p:spPr>
-        <p:txBody>
-          <a:bodyPr anchorCtr="0" anchor="t" bIns="0" lIns="0" spcFirstLastPara="1" rIns="0" wrap="square" tIns="0">
-            <a:noAutofit/>
-          </a:bodyPr>
-          <a:lstStyle/>
-          <a:p>
-            <a:pPr indent="0" lvl="0" marL="0" marR="0" rtl="0" algn="l">
-              <a:spcBef>
-                <a:spcPts val="0"/>
-              </a:spcBef>
-              <a:spcAft>
-                <a:spcPts val="0"/>
-              </a:spcAft>
-              <a:buClr>
-                <a:srgbClr val="0D1B2A"/>
-              </a:buClr>
-              <a:buSzPts val="4000"/>
-              <a:buFont typeface="Spectral"/>
-              <a:buNone/>
-            </a:pPr>
-            <a:r>
-              <a:rPr b="1" i="0" lang="en-US" sz="4000" u="none" cap="none" strike="noStrike">
-                <a:solidFill>
-                  <a:srgbClr val="0D1B2A"/>
-                </a:solidFill>
-                <a:latin typeface="Spectral"/>
-                <a:ea typeface="Spectral"/>
-                <a:cs typeface="Spectral"/>
-                <a:sym typeface="Spectral"/>
-              </a:rPr>
-              <a:t>Hiccups happen. Demo mode is fine.</a:t>
-            </a:r>
-            <a:endParaRPr b="0" i="0" sz="4000" u="none" cap="none" strike="noStrike">
-              <a:solidFill>
-                <a:schemeClr val="dk1"/>
-              </a:solidFill>
-              <a:latin typeface="Calibri"/>
-              <a:ea typeface="Calibri"/>
-              <a:cs typeface="Calibri"/>
-              <a:sym typeface="Calibri"/>
-            </a:endParaRPr>
-          </a:p>
-        </p:txBody>
-      </p:sp>
-      <p:pic>
-        <p:nvPicPr>
-          <p:cNvPr descr="preencoded.png" id="242" name="Google Shape;242;p11"/>
-          <p:cNvPicPr preferRelativeResize="0"/>
-          <p:nvPr/>
-        </p:nvPicPr>
-        <p:blipFill rotWithShape="1">
-          <a:blip r:embed="rId5">
-            <a:alphaModFix/>
-          </a:blip>
-          <a:srcRect b="0" l="0" r="0" t="0"/>
-          <a:stretch/>
-        </p:blipFill>
-        <p:spPr>
-          <a:xfrm>
-            <a:off x="502920" y="2377440"/>
-            <a:ext cx="548640" cy="548640"/>
-          </a:xfrm>
-          <a:prstGeom prst="rect">
-            <a:avLst/>
-          </a:prstGeom>
-          <a:noFill/>
-          <a:ln>
-            <a:noFill/>
-          </a:ln>
-        </p:spPr>
-      </p:pic>
-      <p:sp>
-        <p:nvSpPr>
-          <p:cNvPr id="243" name="Google Shape;243;p11"/>
-          <p:cNvSpPr/>
-          <p:nvPr/>
-        </p:nvSpPr>
-        <p:spPr>
-          <a:xfrm>
-            <a:off x="1234440" y="2331720"/>
-            <a:ext cx="4937760" cy="411480"/>
-          </a:xfrm>
-          <a:prstGeom prst="rect">
-            <a:avLst/>
-          </a:prstGeom>
-          <a:noFill/>
-          <a:ln>
-            <a:noFill/>
-          </a:ln>
-        </p:spPr>
-        <p:txBody>
-          <a:bodyPr anchorCtr="0" anchor="ctr" bIns="0" lIns="0" spcFirstLastPara="1" rIns="0" wrap="square" tIns="0">
-            <a:noAutofit/>
-          </a:bodyPr>
-          <a:lstStyle/>
-          <a:p>
-            <a:pPr indent="0" lvl="0" marL="0" marR="0" rtl="0" algn="l">
-              <a:spcBef>
-                <a:spcPts val="0"/>
-              </a:spcBef>
-              <a:spcAft>
-                <a:spcPts val="0"/>
-              </a:spcAft>
-              <a:buClr>
-                <a:srgbClr val="0D1B2A"/>
-              </a:buClr>
-              <a:buSzPts val="1800"/>
-              <a:buFont typeface="Spectral"/>
-              <a:buNone/>
-            </a:pPr>
-            <a:r>
-              <a:rPr b="1" i="0" lang="en-US" sz="1800" u="none" cap="none" strike="noStrike">
-                <a:solidFill>
-                  <a:srgbClr val="0D1B2A"/>
-                </a:solidFill>
-                <a:latin typeface="Spectral"/>
-                <a:ea typeface="Spectral"/>
-                <a:cs typeface="Spectral"/>
-                <a:sym typeface="Spectral"/>
-              </a:rPr>
-              <a:t>We can’t install Python or Docker for you in 90 minutes</a:t>
-            </a:r>
-            <a:endParaRPr b="0" i="0" sz="1800" u="none" cap="none" strike="noStrike">
-              <a:solidFill>
-                <a:schemeClr val="dk1"/>
-              </a:solidFill>
-              <a:latin typeface="Calibri"/>
-              <a:ea typeface="Calibri"/>
-              <a:cs typeface="Calibri"/>
-              <a:sym typeface="Calibri"/>
-            </a:endParaRPr>
-          </a:p>
-        </p:txBody>
-      </p:sp>
-      <p:sp>
-        <p:nvSpPr>
-          <p:cNvPr id="244" name="Google Shape;244;p11"/>
-          <p:cNvSpPr/>
-          <p:nvPr/>
-        </p:nvSpPr>
-        <p:spPr>
-          <a:xfrm>
-            <a:off x="1234440" y="2788920"/>
-            <a:ext cx="4937760" cy="1280160"/>
-          </a:xfrm>
-          <a:prstGeom prst="rect">
-            <a:avLst/>
-          </a:prstGeom>
-          <a:noFill/>
-          <a:ln>
-            <a:noFill/>
-          </a:ln>
-        </p:spPr>
-        <p:txBody>
-          <a:bodyPr anchorCtr="0" anchor="t" bIns="0" lIns="0" spcFirstLastPara="1" rIns="0" wrap="square" tIns="0">
-            <a:noAutofit/>
-          </a:bodyPr>
-          <a:lstStyle/>
-          <a:p>
-            <a:pPr indent="0" lvl="0" marL="0" marR="0" rtl="0" algn="l">
-              <a:spcBef>
-                <a:spcPts val="0"/>
-              </a:spcBef>
-              <a:spcAft>
-                <a:spcPts val="0"/>
-              </a:spcAft>
-              <a:buClr>
-                <a:srgbClr val="202124"/>
-              </a:buClr>
-              <a:buSzPts val="1200"/>
-              <a:buFont typeface="Lato"/>
-              <a:buNone/>
-            </a:pPr>
-            <a:r>
-              <a:rPr b="0" i="0" lang="en-US" sz="1200" u="none" cap="none" strike="noStrike">
-                <a:solidFill>
-                  <a:srgbClr val="202124"/>
-                </a:solidFill>
-                <a:latin typeface="Lato"/>
-                <a:ea typeface="Lato"/>
-                <a:cs typeface="Lato"/>
-                <a:sym typeface="Lato"/>
-              </a:rPr>
-              <a:t>Conference wifi</a:t>
-            </a:r>
-            <a:endParaRPr b="0" i="0" sz="1200" u="none" cap="none" strike="noStrike">
-              <a:solidFill>
-                <a:srgbClr val="202124"/>
-              </a:solidFill>
-              <a:latin typeface="Lato"/>
-              <a:ea typeface="Lato"/>
-              <a:cs typeface="Lato"/>
-              <a:sym typeface="Lato"/>
-            </a:endParaRPr>
-          </a:p>
-          <a:p>
-            <a:pPr indent="0" lvl="0" marL="0" marR="0" rtl="0" algn="l">
-              <a:spcBef>
-                <a:spcPts val="0"/>
-              </a:spcBef>
-              <a:spcAft>
-                <a:spcPts val="0"/>
-              </a:spcAft>
-              <a:buClr>
-                <a:srgbClr val="202124"/>
-              </a:buClr>
-              <a:buSzPts val="1200"/>
-              <a:buFont typeface="Lato"/>
-              <a:buNone/>
-            </a:pPr>
-            <a:r>
-              <a:rPr b="0" i="0" lang="en-US" sz="1200" u="none" cap="none" strike="noStrike">
-                <a:solidFill>
-                  <a:srgbClr val="202124"/>
-                </a:solidFill>
-                <a:latin typeface="Lato"/>
-                <a:ea typeface="Lato"/>
-                <a:cs typeface="Lato"/>
-                <a:sym typeface="Lato"/>
-              </a:rPr>
-              <a:t>1.5 GB of model weights on shared wifi = slow.</a:t>
-            </a:r>
-            <a:endParaRPr b="0" i="0" sz="1200" u="none" cap="none" strike="noStrike">
-              <a:solidFill>
-                <a:srgbClr val="202124"/>
-              </a:solidFill>
-              <a:latin typeface="Lato"/>
-              <a:ea typeface="Lato"/>
-              <a:cs typeface="Lato"/>
-              <a:sym typeface="Lato"/>
-            </a:endParaRPr>
-          </a:p>
-          <a:p>
-            <a:pPr indent="0" lvl="0" marL="0" marR="0" rtl="0" algn="l">
-              <a:spcBef>
-                <a:spcPts val="0"/>
-              </a:spcBef>
-              <a:spcAft>
-                <a:spcPts val="0"/>
-              </a:spcAft>
-              <a:buClr>
-                <a:srgbClr val="202124"/>
-              </a:buClr>
-              <a:buSzPts val="1200"/>
-              <a:buFont typeface="Lato"/>
-              <a:buNone/>
-            </a:pPr>
-            <a:r>
-              <a:rPr b="0" i="0" lang="en-US" sz="1200" u="none" cap="none" strike="noStrike">
-                <a:solidFill>
-                  <a:srgbClr val="202124"/>
-                </a:solidFill>
-                <a:latin typeface="Lato"/>
-                <a:ea typeface="Lato"/>
-                <a:cs typeface="Lato"/>
-                <a:sym typeface="Lato"/>
-              </a:rPr>
-              <a:t>Watch the demo. Run it tonight at home.</a:t>
-            </a:r>
-            <a:endParaRPr b="0" i="0" sz="1200" u="none" cap="none" strike="noStrike">
-              <a:solidFill>
-                <a:schemeClr val="dk1"/>
-              </a:solidFill>
-              <a:latin typeface="Calibri"/>
-              <a:ea typeface="Calibri"/>
-              <a:cs typeface="Calibri"/>
-              <a:sym typeface="Calibri"/>
-            </a:endParaRPr>
-          </a:p>
-        </p:txBody>
-      </p:sp>
-      <p:pic>
-        <p:nvPicPr>
-          <p:cNvPr descr="preencoded.png" id="245" name="Google Shape;245;p11"/>
-          <p:cNvPicPr preferRelativeResize="0"/>
-          <p:nvPr/>
-        </p:nvPicPr>
-        <p:blipFill rotWithShape="1">
-          <a:blip r:embed="rId6">
-            <a:alphaModFix/>
-          </a:blip>
-          <a:srcRect b="0" l="0" r="0" t="0"/>
-          <a:stretch/>
-        </p:blipFill>
-        <p:spPr>
-          <a:xfrm>
-            <a:off x="6217920" y="2377440"/>
-            <a:ext cx="548640" cy="548640"/>
-          </a:xfrm>
-          <a:prstGeom prst="rect">
-            <a:avLst/>
-          </a:prstGeom>
-          <a:noFill/>
-          <a:ln>
-            <a:noFill/>
-          </a:ln>
-        </p:spPr>
-      </p:pic>
-      <p:sp>
-        <p:nvSpPr>
-          <p:cNvPr id="246" name="Google Shape;246;p11"/>
-          <p:cNvSpPr/>
-          <p:nvPr/>
-        </p:nvSpPr>
-        <p:spPr>
-          <a:xfrm>
-            <a:off x="6949440" y="2331720"/>
-            <a:ext cx="4937760" cy="411480"/>
-          </a:xfrm>
-          <a:prstGeom prst="rect">
-            <a:avLst/>
-          </a:prstGeom>
-          <a:noFill/>
-          <a:ln>
-            <a:noFill/>
-          </a:ln>
-        </p:spPr>
-        <p:txBody>
-          <a:bodyPr anchorCtr="0" anchor="ctr" bIns="0" lIns="0" spcFirstLastPara="1" rIns="0" wrap="square" tIns="0">
-            <a:noAutofit/>
-          </a:bodyPr>
-          <a:lstStyle/>
-          <a:p>
-            <a:pPr indent="0" lvl="0" marL="0" marR="0" rtl="0" algn="l">
-              <a:spcBef>
-                <a:spcPts val="0"/>
-              </a:spcBef>
-              <a:spcAft>
-                <a:spcPts val="0"/>
-              </a:spcAft>
-              <a:buClr>
-                <a:srgbClr val="0D1B2A"/>
-              </a:buClr>
-              <a:buSzPts val="1800"/>
-              <a:buFont typeface="Spectral"/>
-              <a:buNone/>
-            </a:pPr>
-            <a:r>
-              <a:rPr b="1" i="0" lang="en-US" sz="1800" u="none" cap="none" strike="noStrike">
-                <a:solidFill>
-                  <a:srgbClr val="0D1B2A"/>
-                </a:solidFill>
-                <a:latin typeface="Spectral"/>
-                <a:ea typeface="Spectral"/>
-                <a:cs typeface="Spectral"/>
-                <a:sym typeface="Spectral"/>
-              </a:rPr>
-              <a:t>Corp laptop locked down</a:t>
-            </a:r>
-            <a:endParaRPr b="0" i="0" sz="1800" u="none" cap="none" strike="noStrike">
-              <a:solidFill>
-                <a:schemeClr val="dk1"/>
-              </a:solidFill>
-              <a:latin typeface="Calibri"/>
-              <a:ea typeface="Calibri"/>
-              <a:cs typeface="Calibri"/>
-              <a:sym typeface="Calibri"/>
-            </a:endParaRPr>
-          </a:p>
-        </p:txBody>
-      </p:sp>
-      <p:sp>
-        <p:nvSpPr>
-          <p:cNvPr id="247" name="Google Shape;247;p11"/>
-          <p:cNvSpPr/>
-          <p:nvPr/>
-        </p:nvSpPr>
-        <p:spPr>
-          <a:xfrm>
-            <a:off x="6949440" y="2788920"/>
-            <a:ext cx="4937760" cy="1280160"/>
-          </a:xfrm>
-          <a:prstGeom prst="rect">
-            <a:avLst/>
-          </a:prstGeom>
-          <a:noFill/>
-          <a:ln>
-            <a:noFill/>
-          </a:ln>
-        </p:spPr>
-        <p:txBody>
-          <a:bodyPr anchorCtr="0" anchor="t" bIns="0" lIns="0" spcFirstLastPara="1" rIns="0" wrap="square" tIns="0">
-            <a:noAutofit/>
-          </a:bodyPr>
-          <a:lstStyle/>
-          <a:p>
-            <a:pPr indent="0" lvl="0" marL="0" marR="0" rtl="0" algn="l">
-              <a:spcBef>
-                <a:spcPts val="0"/>
-              </a:spcBef>
-              <a:spcAft>
-                <a:spcPts val="0"/>
-              </a:spcAft>
-              <a:buClr>
-                <a:srgbClr val="202124"/>
-              </a:buClr>
-              <a:buSzPts val="1200"/>
-              <a:buFont typeface="Lato"/>
-              <a:buNone/>
-            </a:pPr>
-            <a:r>
-              <a:rPr b="0" i="0" lang="en-US" sz="1200" u="none" cap="none" strike="noStrike">
-                <a:solidFill>
-                  <a:srgbClr val="202124"/>
-                </a:solidFill>
-                <a:latin typeface="Lato"/>
-                <a:ea typeface="Lato"/>
-                <a:cs typeface="Lato"/>
-                <a:sym typeface="Lato"/>
-              </a:rPr>
-              <a:t>Blocked Docker, blocked pip, blocked curl|sh?</a:t>
-            </a:r>
-            <a:endParaRPr b="0" i="0" sz="1200" u="none" cap="none" strike="noStrike">
-              <a:solidFill>
-                <a:srgbClr val="202124"/>
-              </a:solidFill>
-              <a:latin typeface="Lato"/>
-              <a:ea typeface="Lato"/>
-              <a:cs typeface="Lato"/>
-              <a:sym typeface="Lato"/>
-            </a:endParaRPr>
-          </a:p>
-          <a:p>
-            <a:pPr indent="0" lvl="0" marL="0" marR="0" rtl="0" algn="l">
-              <a:spcBef>
-                <a:spcPts val="0"/>
-              </a:spcBef>
-              <a:spcAft>
-                <a:spcPts val="0"/>
-              </a:spcAft>
-              <a:buClr>
-                <a:srgbClr val="202124"/>
-              </a:buClr>
-              <a:buSzPts val="1200"/>
-              <a:buFont typeface="Lato"/>
-              <a:buNone/>
-            </a:pPr>
-            <a:r>
-              <a:rPr b="0" i="0" lang="en-US" sz="1200" u="none" cap="none" strike="noStrike">
-                <a:solidFill>
-                  <a:srgbClr val="202124"/>
-                </a:solidFill>
-                <a:latin typeface="Lato"/>
-                <a:ea typeface="Lato"/>
-                <a:cs typeface="Lato"/>
-                <a:sym typeface="Lato"/>
-              </a:rPr>
-              <a:t>Watch the demo. Run it on a personal machine.</a:t>
-            </a:r>
-            <a:endParaRPr b="0" i="0" sz="1200" u="none" cap="none" strike="noStrike">
-              <a:solidFill>
-                <a:schemeClr val="dk1"/>
-              </a:solidFill>
-              <a:latin typeface="Calibri"/>
-              <a:ea typeface="Calibri"/>
-              <a:cs typeface="Calibri"/>
-              <a:sym typeface="Calibri"/>
-            </a:endParaRPr>
-          </a:p>
-        </p:txBody>
-      </p:sp>
-      <p:pic>
-        <p:nvPicPr>
-          <p:cNvPr descr="preencoded.png" id="248" name="Google Shape;248;p11"/>
-          <p:cNvPicPr preferRelativeResize="0"/>
-          <p:nvPr/>
-        </p:nvPicPr>
-        <p:blipFill rotWithShape="1">
-          <a:blip r:embed="rId7">
-            <a:alphaModFix/>
-          </a:blip>
-          <a:srcRect b="0" l="0" r="0" t="0"/>
-          <a:stretch/>
-        </p:blipFill>
-        <p:spPr>
-          <a:xfrm>
-            <a:off x="502920" y="4206240"/>
-            <a:ext cx="548640" cy="548640"/>
-          </a:xfrm>
-          <a:prstGeom prst="rect">
-            <a:avLst/>
-          </a:prstGeom>
-          <a:noFill/>
-          <a:ln>
-            <a:noFill/>
-          </a:ln>
-        </p:spPr>
-      </p:pic>
-      <p:sp>
-        <p:nvSpPr>
-          <p:cNvPr id="249" name="Google Shape;249;p11"/>
-          <p:cNvSpPr/>
-          <p:nvPr/>
-        </p:nvSpPr>
-        <p:spPr>
-          <a:xfrm>
-            <a:off x="1234440" y="4160520"/>
-            <a:ext cx="4937760" cy="411480"/>
-          </a:xfrm>
-          <a:prstGeom prst="rect">
-            <a:avLst/>
-          </a:prstGeom>
-          <a:noFill/>
-          <a:ln>
-            <a:noFill/>
-          </a:ln>
-        </p:spPr>
-        <p:txBody>
-          <a:bodyPr anchorCtr="0" anchor="ctr" bIns="0" lIns="0" spcFirstLastPara="1" rIns="0" wrap="square" tIns="0">
-            <a:noAutofit/>
-          </a:bodyPr>
-          <a:lstStyle/>
-          <a:p>
-            <a:pPr indent="0" lvl="0" marL="0" marR="0" rtl="0" algn="l">
-              <a:spcBef>
-                <a:spcPts val="0"/>
-              </a:spcBef>
-              <a:spcAft>
-                <a:spcPts val="0"/>
-              </a:spcAft>
-              <a:buClr>
-                <a:srgbClr val="0D1B2A"/>
-              </a:buClr>
-              <a:buSzPts val="1800"/>
-              <a:buFont typeface="Spectral"/>
-              <a:buNone/>
-            </a:pPr>
-            <a:r>
-              <a:rPr b="1" i="0" lang="en-US" sz="1800" u="none" cap="none" strike="noStrike">
-                <a:solidFill>
-                  <a:srgbClr val="0D1B2A"/>
-                </a:solidFill>
-                <a:latin typeface="Spectral"/>
-                <a:ea typeface="Spectral"/>
-                <a:cs typeface="Spectral"/>
-                <a:sym typeface="Spectral"/>
-              </a:rPr>
-              <a:t>No Docker Desktop installed</a:t>
-            </a:r>
-            <a:endParaRPr b="0" i="0" sz="1800" u="none" cap="none" strike="noStrike">
-              <a:solidFill>
-                <a:schemeClr val="dk1"/>
-              </a:solidFill>
-              <a:latin typeface="Calibri"/>
-              <a:ea typeface="Calibri"/>
-              <a:cs typeface="Calibri"/>
-              <a:sym typeface="Calibri"/>
-            </a:endParaRPr>
-          </a:p>
-        </p:txBody>
-      </p:sp>
-      <p:sp>
-        <p:nvSpPr>
-          <p:cNvPr id="250" name="Google Shape;250;p11"/>
-          <p:cNvSpPr/>
-          <p:nvPr/>
-        </p:nvSpPr>
-        <p:spPr>
-          <a:xfrm>
-            <a:off x="1234440" y="4617720"/>
-            <a:ext cx="4937760" cy="1280160"/>
-          </a:xfrm>
-          <a:prstGeom prst="rect">
-            <a:avLst/>
-          </a:prstGeom>
-          <a:noFill/>
-          <a:ln>
-            <a:noFill/>
-          </a:ln>
-        </p:spPr>
-        <p:txBody>
-          <a:bodyPr anchorCtr="0" anchor="t" bIns="0" lIns="0" spcFirstLastPara="1" rIns="0" wrap="square" tIns="0">
-            <a:noAutofit/>
-          </a:bodyPr>
-          <a:lstStyle/>
-          <a:p>
-            <a:pPr indent="0" lvl="0" marL="0" marR="0" rtl="0" algn="l">
-              <a:spcBef>
-                <a:spcPts val="0"/>
-              </a:spcBef>
-              <a:spcAft>
-                <a:spcPts val="0"/>
-              </a:spcAft>
-              <a:buClr>
-                <a:srgbClr val="202124"/>
-              </a:buClr>
-              <a:buSzPts val="1200"/>
-              <a:buFont typeface="Lato"/>
-              <a:buNone/>
-            </a:pPr>
-            <a:r>
-              <a:rPr b="0" i="0" lang="en-US" sz="1200" u="none" cap="none" strike="noStrike">
-                <a:solidFill>
-                  <a:srgbClr val="202124"/>
-                </a:solidFill>
-                <a:latin typeface="Lato"/>
-                <a:ea typeface="Lato"/>
-                <a:cs typeface="Lato"/>
-                <a:sym typeface="Lato"/>
-              </a:rPr>
-              <a:t>setup.sh checks first and exits clean. Watch the demo. Install at home.</a:t>
-            </a:r>
-            <a:endParaRPr b="0" i="0" sz="1200" u="none" cap="none" strike="noStrike">
-              <a:solidFill>
-                <a:schemeClr val="dk1"/>
-              </a:solidFill>
-              <a:latin typeface="Calibri"/>
-              <a:ea typeface="Calibri"/>
-              <a:cs typeface="Calibri"/>
-              <a:sym typeface="Calibri"/>
-            </a:endParaRPr>
-          </a:p>
-        </p:txBody>
-      </p:sp>
-      <p:pic>
-        <p:nvPicPr>
-          <p:cNvPr descr="preencoded.png" id="251" name="Google Shape;251;p11"/>
-          <p:cNvPicPr preferRelativeResize="0"/>
-          <p:nvPr/>
-        </p:nvPicPr>
-        <p:blipFill rotWithShape="1">
-          <a:blip r:embed="rId8">
-            <a:alphaModFix/>
-          </a:blip>
-          <a:srcRect b="0" l="0" r="0" t="0"/>
-          <a:stretch/>
-        </p:blipFill>
-        <p:spPr>
-          <a:xfrm>
-            <a:off x="6217920" y="4206240"/>
-            <a:ext cx="548640" cy="548640"/>
-          </a:xfrm>
-          <a:prstGeom prst="rect">
-            <a:avLst/>
-          </a:prstGeom>
-          <a:noFill/>
-          <a:ln>
-            <a:noFill/>
-          </a:ln>
-        </p:spPr>
-      </p:pic>
-      <p:sp>
-        <p:nvSpPr>
-          <p:cNvPr id="252" name="Google Shape;252;p11"/>
-          <p:cNvSpPr/>
-          <p:nvPr/>
-        </p:nvSpPr>
-        <p:spPr>
-          <a:xfrm>
-            <a:off x="6949440" y="4160520"/>
-            <a:ext cx="4937760" cy="411480"/>
-          </a:xfrm>
-          <a:prstGeom prst="rect">
-            <a:avLst/>
-          </a:prstGeom>
-          <a:noFill/>
-          <a:ln>
-            <a:noFill/>
-          </a:ln>
-        </p:spPr>
-        <p:txBody>
-          <a:bodyPr anchorCtr="0" anchor="ctr" bIns="0" lIns="0" spcFirstLastPara="1" rIns="0" wrap="square" tIns="0">
-            <a:noAutofit/>
-          </a:bodyPr>
-          <a:lstStyle/>
-          <a:p>
-            <a:pPr indent="0" lvl="0" marL="0" marR="0" rtl="0" algn="l">
-              <a:spcBef>
-                <a:spcPts val="0"/>
-              </a:spcBef>
-              <a:spcAft>
-                <a:spcPts val="0"/>
-              </a:spcAft>
-              <a:buClr>
-                <a:srgbClr val="0D1B2A"/>
-              </a:buClr>
-              <a:buSzPts val="1800"/>
-              <a:buFont typeface="Spectral"/>
-              <a:buNone/>
-            </a:pPr>
-            <a:r>
-              <a:rPr b="1" i="0" lang="en-US" sz="1800" u="none" cap="none" strike="noStrike">
-                <a:solidFill>
-                  <a:srgbClr val="0D1B2A"/>
-                </a:solidFill>
-                <a:latin typeface="Spectral"/>
-                <a:ea typeface="Spectral"/>
-                <a:cs typeface="Spectral"/>
-                <a:sym typeface="Spectral"/>
-              </a:rPr>
-              <a:t>Windows without WSL</a:t>
-            </a:r>
-            <a:endParaRPr b="0" i="0" sz="1800" u="none" cap="none" strike="noStrike">
-              <a:solidFill>
-                <a:schemeClr val="dk1"/>
-              </a:solidFill>
-              <a:latin typeface="Calibri"/>
-              <a:ea typeface="Calibri"/>
-              <a:cs typeface="Calibri"/>
-              <a:sym typeface="Calibri"/>
-            </a:endParaRPr>
-          </a:p>
-        </p:txBody>
-      </p:sp>
-      <p:sp>
-        <p:nvSpPr>
-          <p:cNvPr id="253" name="Google Shape;253;p11"/>
-          <p:cNvSpPr/>
-          <p:nvPr/>
-        </p:nvSpPr>
-        <p:spPr>
-          <a:xfrm>
-            <a:off x="6949440" y="4617720"/>
-            <a:ext cx="4937760" cy="1280160"/>
-          </a:xfrm>
-          <a:prstGeom prst="rect">
-            <a:avLst/>
-          </a:prstGeom>
-          <a:noFill/>
-          <a:ln>
-            <a:noFill/>
-          </a:ln>
-        </p:spPr>
-        <p:txBody>
-          <a:bodyPr anchorCtr="0" anchor="t" bIns="0" lIns="0" spcFirstLastPara="1" rIns="0" wrap="square" tIns="0">
-            <a:noAutofit/>
-          </a:bodyPr>
-          <a:lstStyle/>
-          <a:p>
-            <a:pPr indent="0" lvl="0" marL="0" marR="0" rtl="0" algn="l">
-              <a:spcBef>
-                <a:spcPts val="0"/>
-              </a:spcBef>
-              <a:spcAft>
-                <a:spcPts val="0"/>
-              </a:spcAft>
-              <a:buClr>
-                <a:srgbClr val="202124"/>
-              </a:buClr>
-              <a:buSzPts val="1200"/>
-              <a:buFont typeface="Lato"/>
-              <a:buNone/>
-            </a:pPr>
-            <a:r>
-              <a:rPr b="0" i="0" lang="en-US" sz="1200" u="none" cap="none" strike="noStrike">
-                <a:solidFill>
-                  <a:srgbClr val="202124"/>
-                </a:solidFill>
-                <a:latin typeface="Lato"/>
-                <a:ea typeface="Lato"/>
-                <a:cs typeface="Lato"/>
-                <a:sym typeface="Lato"/>
-              </a:rPr>
-              <a:t>setup.sh is Mac/Linux/WSL. WSL is a 5-minute install — do it tonight.</a:t>
-            </a:r>
-            <a:endParaRPr b="0" i="0" sz="1200" u="none" cap="none" strike="noStrike">
-              <a:solidFill>
-                <a:schemeClr val="dk1"/>
-              </a:solidFill>
-              <a:latin typeface="Calibri"/>
-              <a:ea typeface="Calibri"/>
-              <a:cs typeface="Calibri"/>
-              <a:sym typeface="Calibri"/>
-            </a:endParaRPr>
-          </a:p>
-        </p:txBody>
-      </p:sp>
-      <p:pic>
-        <p:nvPicPr>
-          <p:cNvPr id="254" name="Google Shape;254;p11" title="Gemini_Generated_Image_rbdzoirbdzoirbdz.png"/>
-          <p:cNvPicPr preferRelativeResize="0"/>
-          <p:nvPr/>
-        </p:nvPicPr>
-        <p:blipFill rotWithShape="1">
-          <a:blip r:embed="rId9">
-            <a:alphaModFix/>
-          </a:blip>
-          <a:srcRect b="33061" l="22742" r="28149" t="10923"/>
-          <a:stretch/>
-        </p:blipFill>
-        <p:spPr>
-          <a:xfrm>
-            <a:off x="9885440" y="6291673"/>
-            <a:ext cx="1727432" cy="492600"/>
-          </a:xfrm>
-          <a:prstGeom prst="rect">
-            <a:avLst/>
-          </a:prstGeom>
-          <a:noFill/>
-          <a:ln>
-            <a:noFill/>
-          </a:ln>
-        </p:spPr>
-      </p:pic>
-    </p:spTree>
-  </p:cSld>
-  <p:clrMapOvr>
-    <a:masterClrMapping/>
-  </p:clrMapOvr>
-</p:sld>
-</file>
-
-<file path=ppt/slides/slide25.xml><?xml version="1.0" encoding="utf-8"?>
-<p:sld xmlns:a="http://schemas.openxmlformats.org/drawingml/2006/main" xmlns:r="http://schemas.openxmlformats.org/officeDocument/2006/relationships" xmlns:mc="http://schemas.openxmlformats.org/markup-compatibility/2006" xmlns:mv="urn:schemas-microsoft-com:mac:vml" xmlns:p="http://schemas.openxmlformats.org/presentationml/2006/main" xmlns:c="http://schemas.openxmlformats.org/drawingml/2006/chart" xmlns:dgm="http://schemas.openxmlformats.org/drawingml/2006/diagram" xmlns:o="urn:schemas-microsoft-com:office:office" xmlns:v="urn:schemas-microsoft-com:vml" xmlns:pvml="urn:schemas-microsoft-com:office:powerpoint" xmlns:com="http://schemas.openxmlformats.org/drawingml/2006/compatibility" xmlns:p14="http://schemas.microsoft.com/office/powerpoint/2010/main" xmlns:p15="http://schemas.microsoft.com/office/powerpoint/2012/main" xmlns:ahyp="http://schemas.microsoft.com/office/drawing/2018/hyperlinkcolor">
-  <p:cSld>
-    <p:bg>
-      <p:bgPr>
-        <a:solidFill>
-          <a:srgbClr val="FFFFFF"/>
-        </a:solidFill>
-      </p:bgPr>
-    </p:bg>
-    <p:spTree>
-      <p:nvGrpSpPr>
-        <p:cNvPr id="235" name="Shape 235"/>
-        <p:cNvGrpSpPr/>
-        <p:nvPr/>
-      </p:nvGrpSpPr>
-      <p:grpSpPr>
-        <a:xfrm>
-          <a:off x="0" y="0"/>
-          <a:ext cx="0" cy="0"/>
-          <a:chOff x="0" y="0"/>
-          <a:chExt cx="0" cy="0"/>
-        </a:xfrm>
-      </p:grpSpPr>
-      <p:sp>
-        <p:nvSpPr>
-          <p:cNvPr id="236" name="Google Shape;236;p11"/>
-          <p:cNvSpPr/>
-          <p:nvPr/>
-        </p:nvSpPr>
-        <p:spPr>
-          <a:xfrm>
-            <a:off x="9265615" y="457200"/>
-            <a:ext cx="2286000" cy="36576"/>
-          </a:xfrm>
-          <a:prstGeom prst="rect">
-            <a:avLst/>
-          </a:prstGeom>
-          <a:solidFill>
-            <a:srgbClr val="326666"/>
-          </a:solidFill>
-          <a:ln cap="flat" cmpd="sng" w="12700">
-            <a:solidFill>
-              <a:srgbClr val="326666"/>
-            </a:solidFill>
-            <a:prstDash val="solid"/>
-            <a:round/>
-            <a:headEnd len="sm" w="sm" type="none"/>
-            <a:tailEnd len="sm" w="sm" type="none"/>
-          </a:ln>
-        </p:spPr>
-        <p:txBody>
-          <a:bodyPr anchorCtr="0" anchor="ctr" bIns="91425" lIns="91425" spcFirstLastPara="1" rIns="91425" wrap="square" tIns="91425">
-            <a:noAutofit/>
-          </a:bodyPr>
-          <a:lstStyle/>
-          <a:p>
-            <a:pPr indent="0" lvl="0" marL="0" rtl="0" algn="l">
-              <a:spcBef>
-                <a:spcPts val="0"/>
-              </a:spcBef>
-              <a:spcAft>
-                <a:spcPts val="0"/>
-              </a:spcAft>
-              <a:buNone/>
-            </a:pPr>
-            <a:r>
-              <a:t/>
-            </a:r>
-            <a:endParaRPr/>
-          </a:p>
-        </p:txBody>
-      </p:sp>
-      <p:sp>
-        <p:nvSpPr>
-          <p:cNvPr id="237" name="Google Shape;237;p11"/>
-          <p:cNvSpPr/>
-          <p:nvPr/>
-        </p:nvSpPr>
-        <p:spPr>
-          <a:xfrm>
-            <a:off x="9265615" y="548640"/>
-            <a:ext cx="2286000" cy="18288"/>
-          </a:xfrm>
-          <a:prstGeom prst="rect">
-            <a:avLst/>
-          </a:prstGeom>
-          <a:solidFill>
-            <a:srgbClr val="326666"/>
-          </a:solidFill>
-          <a:ln cap="flat" cmpd="sng" w="12700">
-            <a:solidFill>
-              <a:srgbClr val="326666"/>
-            </a:solidFill>
-            <a:prstDash val="solid"/>
-            <a:round/>
-            <a:headEnd len="sm" w="sm" type="none"/>
-            <a:tailEnd len="sm" w="sm" type="none"/>
-          </a:ln>
-        </p:spPr>
-        <p:txBody>
-          <a:bodyPr anchorCtr="0" anchor="ctr" bIns="91425" lIns="91425" spcFirstLastPara="1" rIns="91425" wrap="square" tIns="91425">
-            <a:noAutofit/>
-          </a:bodyPr>
-          <a:lstStyle/>
-          <a:p>
-            <a:pPr indent="0" lvl="0" marL="0" rtl="0" algn="l">
-              <a:spcBef>
-                <a:spcPts val="0"/>
-              </a:spcBef>
-              <a:spcAft>
-                <a:spcPts val="0"/>
-              </a:spcAft>
-              <a:buNone/>
-            </a:pPr>
-            <a:r>
-              <a:t/>
-            </a:r>
-            <a:endParaRPr/>
-          </a:p>
-        </p:txBody>
-      </p:sp>
-      <p:sp>
-        <p:nvSpPr>
-          <p:cNvPr id="238" name="Google Shape;238;p11"/>
-          <p:cNvSpPr/>
-          <p:nvPr/>
-        </p:nvSpPr>
-        <p:spPr>
-          <a:xfrm>
-            <a:off x="502920" y="384048"/>
-            <a:ext cx="914400" cy="320040"/>
-          </a:xfrm>
-          <a:prstGeom prst="rect">
-            <a:avLst/>
-          </a:prstGeom>
-          <a:noFill/>
-          <a:ln>
-            <a:noFill/>
-          </a:ln>
-        </p:spPr>
-        <p:txBody>
-          <a:bodyPr anchorCtr="0" anchor="ctr" bIns="0" lIns="0" spcFirstLastPara="1" rIns="0" wrap="square" tIns="0">
-            <a:noAutofit/>
-          </a:bodyPr>
-          <a:lstStyle/>
-          <a:p>
-            <a:pPr indent="0" lvl="0" marL="0" marR="0" rtl="0" algn="l">
-              <a:spcBef>
-                <a:spcPts val="0"/>
-              </a:spcBef>
-              <a:spcAft>
-                <a:spcPts val="0"/>
-              </a:spcAft>
-              <a:buClr>
-                <a:srgbClr val="0D1B2A"/>
-              </a:buClr>
-              <a:buSzPts val="1300"/>
-              <a:buFont typeface="Lato"/>
-              <a:buNone/>
-            </a:pPr>
-            <a:r>
-              <a:rPr b="1" i="0" lang="en-US" sz="1300" u="none" cap="none" strike="noStrike">
-                <a:solidFill>
-                  <a:srgbClr val="0D1B2A"/>
-                </a:solidFill>
-                <a:latin typeface="Lato"/>
-                <a:ea typeface="Lato"/>
-                <a:cs typeface="Lato"/>
-                <a:sym typeface="Lato"/>
-              </a:rPr>
-              <a:t>01</a:t>
-            </a:r>
-            <a:endParaRPr b="0" i="0" sz="1300" u="none" cap="none" strike="noStrike">
-              <a:solidFill>
-                <a:schemeClr val="dk1"/>
-              </a:solidFill>
-              <a:latin typeface="Calibri"/>
-              <a:ea typeface="Calibri"/>
-              <a:cs typeface="Calibri"/>
-              <a:sym typeface="Calibri"/>
-            </a:endParaRPr>
-          </a:p>
-        </p:txBody>
-      </p:sp>
-      <p:sp>
-        <p:nvSpPr>
-          <p:cNvPr id="239" name="Google Shape;239;p11">
-            <a:hlinkClick r:id="rId3"/>
-          </p:cNvPr>
-          <p:cNvSpPr/>
-          <p:nvPr/>
-        </p:nvSpPr>
-        <p:spPr>
-          <a:xfrm>
-            <a:off x="502920" y="6446520"/>
-            <a:ext cx="2743200" cy="274320"/>
-          </a:xfrm>
-          <a:prstGeom prst="rect">
-            <a:avLst/>
-          </a:prstGeom>
-          <a:noFill/>
-          <a:ln>
-            <a:noFill/>
-          </a:ln>
-        </p:spPr>
-        <p:txBody>
-          <a:bodyPr anchorCtr="0" anchor="ctr" bIns="0" lIns="0" spcFirstLastPara="1" rIns="0" wrap="square" tIns="0">
-            <a:noAutofit/>
-          </a:bodyPr>
-          <a:lstStyle/>
-          <a:p>
-            <a:pPr indent="0" lvl="0" marL="0" marR="0" rtl="0" algn="l">
-              <a:spcBef>
-                <a:spcPts val="0"/>
-              </a:spcBef>
-              <a:spcAft>
-                <a:spcPts val="0"/>
-              </a:spcAft>
-              <a:buClr>
-                <a:srgbClr val="595959"/>
-              </a:buClr>
-              <a:buSzPts val="1000"/>
-              <a:buFont typeface="Lato"/>
-              <a:buNone/>
-            </a:pPr>
-            <a:r>
-              <a:rPr b="0" i="0" lang="en-US" sz="1000" u="sng" cap="none" strike="noStrike">
-                <a:solidFill>
-                  <a:schemeClr val="hlink"/>
-                </a:solidFill>
-                <a:latin typeface="Lato"/>
-                <a:ea typeface="Lato"/>
-                <a:cs typeface="Lato"/>
-                <a:sym typeface="Lato"/>
-                <a:hlinkClick r:id="rId4"/>
-              </a:rPr>
-              <a:t>www.arsinnovate.com</a:t>
-            </a:r>
-            <a:endParaRPr b="0" i="0" sz="1000" u="none" cap="none" strike="noStrike">
-              <a:solidFill>
-                <a:schemeClr val="dk1"/>
-              </a:solidFill>
-              <a:latin typeface="Calibri"/>
-              <a:ea typeface="Calibri"/>
-              <a:cs typeface="Calibri"/>
-              <a:sym typeface="Calibri"/>
-            </a:endParaRPr>
-          </a:p>
-        </p:txBody>
-      </p:sp>
-      <p:sp>
-        <p:nvSpPr>
-          <p:cNvPr id="240" name="Google Shape;240;p11"/>
-          <p:cNvSpPr/>
-          <p:nvPr/>
-        </p:nvSpPr>
-        <p:spPr>
-          <a:xfrm>
-            <a:off x="11551615" y="6400800"/>
-            <a:ext cx="365760" cy="274320"/>
-          </a:xfrm>
-          <a:prstGeom prst="rect">
-            <a:avLst/>
-          </a:prstGeom>
-          <a:noFill/>
-          <a:ln>
-            <a:noFill/>
-          </a:ln>
-        </p:spPr>
-        <p:txBody>
-          <a:bodyPr anchorCtr="0" anchor="ctr" bIns="0" lIns="0" spcFirstLastPara="1" rIns="0" wrap="square" tIns="0">
-            <a:noAutofit/>
-          </a:bodyPr>
-          <a:lstStyle/>
-          <a:p>
-            <a:pPr indent="0" lvl="0" marL="0" marR="0" rtl="0" algn="r">
-              <a:spcBef>
-                <a:spcPts val="0"/>
-              </a:spcBef>
-              <a:spcAft>
-                <a:spcPts val="0"/>
-              </a:spcAft>
-              <a:buClr>
-                <a:srgbClr val="595959"/>
-              </a:buClr>
-              <a:buSzPts val="1100"/>
-              <a:buFont typeface="Lato"/>
-              <a:buNone/>
-            </a:pPr>
-            <a:r>
-              <a:rPr b="0" i="0" lang="en-US" sz="1100" u="none" cap="none" strike="noStrike">
-                <a:solidFill>
-                  <a:srgbClr val="595959"/>
-                </a:solidFill>
-                <a:latin typeface="Lato"/>
-                <a:ea typeface="Lato"/>
-                <a:cs typeface="Lato"/>
-                <a:sym typeface="Lato"/>
-              </a:rPr>
-              <a:t>8</a:t>
-            </a:r>
-            <a:endParaRPr b="0" i="0" sz="1100" u="none" cap="none" strike="noStrike">
-              <a:solidFill>
-                <a:schemeClr val="dk1"/>
-              </a:solidFill>
-              <a:latin typeface="Calibri"/>
-              <a:ea typeface="Calibri"/>
-              <a:cs typeface="Calibri"/>
-              <a:sym typeface="Calibri"/>
-            </a:endParaRPr>
-          </a:p>
-        </p:txBody>
-      </p:sp>
-      <p:sp>
-        <p:nvSpPr>
-          <p:cNvPr id="241" name="Google Shape;241;p11"/>
-          <p:cNvSpPr/>
-          <p:nvPr/>
-        </p:nvSpPr>
-        <p:spPr>
-          <a:xfrm>
-            <a:off x="502920" y="960120"/>
-            <a:ext cx="11185855" cy="1097280"/>
-          </a:xfrm>
-          <a:prstGeom prst="rect">
-            <a:avLst/>
-          </a:prstGeom>
-          <a:noFill/>
-          <a:ln>
-            <a:noFill/>
-          </a:ln>
-        </p:spPr>
-        <p:txBody>
-          <a:bodyPr anchorCtr="0" anchor="t" bIns="0" lIns="0" spcFirstLastPara="1" rIns="0" wrap="square" tIns="0">
-            <a:noAutofit/>
-          </a:bodyPr>
-          <a:lstStyle/>
-          <a:p>
-            <a:pPr indent="0" lvl="0" marL="0" marR="0" rtl="0" algn="l">
-              <a:spcBef>
-                <a:spcPts val="0"/>
-              </a:spcBef>
-              <a:spcAft>
-                <a:spcPts val="0"/>
-              </a:spcAft>
-              <a:buClr>
-                <a:srgbClr val="0D1B2A"/>
-              </a:buClr>
-              <a:buSzPts val="4000"/>
-              <a:buFont typeface="Spectral"/>
-              <a:buNone/>
-            </a:pPr>
-            <a:r>
-              <a:rPr b="1" i="0" lang="en-US" sz="4000" u="none" cap="none" strike="noStrike">
-                <a:solidFill>
-                  <a:srgbClr val="0D1B2A"/>
-                </a:solidFill>
-                <a:latin typeface="Spectral"/>
-                <a:ea typeface="Spectral"/>
-                <a:cs typeface="Spectral"/>
-                <a:sym typeface="Spectral"/>
-              </a:rPr>
-              <a:t>Three short docs. That’s our knowledge base.</a:t>
-            </a:r>
-            <a:endParaRPr b="0" i="0" sz="4000" u="none" cap="none" strike="noStrike">
-              <a:solidFill>
-                <a:schemeClr val="dk1"/>
-              </a:solidFill>
-              <a:latin typeface="Calibri"/>
-              <a:ea typeface="Calibri"/>
-              <a:cs typeface="Calibri"/>
-              <a:sym typeface="Calibri"/>
-            </a:endParaRPr>
-          </a:p>
-        </p:txBody>
-      </p:sp>
-      <p:pic>
-        <p:nvPicPr>
-          <p:cNvPr descr="preencoded.png" id="242" name="Google Shape;242;p11"/>
-          <p:cNvPicPr preferRelativeResize="0"/>
-          <p:nvPr/>
-        </p:nvPicPr>
-        <p:blipFill rotWithShape="1">
-          <a:blip r:embed="rId5">
-            <a:alphaModFix/>
-          </a:blip>
-          <a:srcRect b="0" l="0" r="0" t="0"/>
-          <a:stretch/>
-        </p:blipFill>
-        <p:spPr>
-          <a:xfrm>
-            <a:off x="502920" y="2377440"/>
-            <a:ext cx="548640" cy="548640"/>
-          </a:xfrm>
-          <a:prstGeom prst="rect">
-            <a:avLst/>
-          </a:prstGeom>
-          <a:noFill/>
-          <a:ln>
-            <a:noFill/>
-          </a:ln>
-        </p:spPr>
-      </p:pic>
-      <p:sp>
-        <p:nvSpPr>
-          <p:cNvPr id="243" name="Google Shape;243;p11"/>
-          <p:cNvSpPr/>
-          <p:nvPr/>
-        </p:nvSpPr>
-        <p:spPr>
-          <a:xfrm>
-            <a:off x="1234440" y="2331720"/>
-            <a:ext cx="4937760" cy="411480"/>
-          </a:xfrm>
-          <a:prstGeom prst="rect">
-            <a:avLst/>
-          </a:prstGeom>
-          <a:noFill/>
-          <a:ln>
-            <a:noFill/>
-          </a:ln>
-        </p:spPr>
-        <p:txBody>
-          <a:bodyPr anchorCtr="0" anchor="ctr" bIns="0" lIns="0" spcFirstLastPara="1" rIns="0" wrap="square" tIns="0">
-            <a:noAutofit/>
-          </a:bodyPr>
-          <a:lstStyle/>
-          <a:p>
-            <a:pPr indent="0" lvl="0" marL="0" marR="0" rtl="0" algn="l">
-              <a:spcBef>
-                <a:spcPts val="0"/>
-              </a:spcBef>
-              <a:spcAft>
-                <a:spcPts val="0"/>
-              </a:spcAft>
-              <a:buClr>
-                <a:srgbClr val="0D1B2A"/>
-              </a:buClr>
-              <a:buSzPts val="1800"/>
-              <a:buFont typeface="Spectral"/>
-              <a:buNone/>
-            </a:pPr>
-            <a:r>
-              <a:rPr b="1" i="0" lang="en-US" sz="1800" u="none" cap="none" strike="noStrike">
-                <a:solidFill>
-                  <a:srgbClr val="0D1B2A"/>
-                </a:solidFill>
-                <a:latin typeface="Spectral"/>
-                <a:ea typeface="Spectral"/>
-                <a:cs typeface="Spectral"/>
-                <a:sym typeface="Spectral"/>
-              </a:rPr>
-              <a:t>What our RAG retrieves from</a:t>
-            </a:r>
-            <a:endParaRPr b="0" i="0" sz="1800" u="none" cap="none" strike="noStrike">
-              <a:solidFill>
-                <a:schemeClr val="dk1"/>
-              </a:solidFill>
-              <a:latin typeface="Calibri"/>
-              <a:ea typeface="Calibri"/>
-              <a:cs typeface="Calibri"/>
-              <a:sym typeface="Calibri"/>
-            </a:endParaRPr>
-          </a:p>
-        </p:txBody>
-      </p:sp>
-      <p:sp>
-        <p:nvSpPr>
-          <p:cNvPr id="244" name="Google Shape;244;p11"/>
-          <p:cNvSpPr/>
-          <p:nvPr/>
-        </p:nvSpPr>
-        <p:spPr>
-          <a:xfrm>
-            <a:off x="1234440" y="2788920"/>
-            <a:ext cx="4937760" cy="1280160"/>
-          </a:xfrm>
-          <a:prstGeom prst="rect">
-            <a:avLst/>
-          </a:prstGeom>
-          <a:noFill/>
-          <a:ln>
-            <a:noFill/>
-          </a:ln>
-        </p:spPr>
-        <p:txBody>
-          <a:bodyPr anchorCtr="0" anchor="t" bIns="0" lIns="0" spcFirstLastPara="1" rIns="0" wrap="square" tIns="0">
-            <a:noAutofit/>
-          </a:bodyPr>
-          <a:lstStyle/>
-          <a:p>
-            <a:pPr indent="0" lvl="0" marL="0" marR="0" rtl="0" algn="l">
-              <a:spcBef>
-                <a:spcPts val="0"/>
-              </a:spcBef>
-              <a:spcAft>
-                <a:spcPts val="0"/>
-              </a:spcAft>
-              <a:buClr>
-                <a:srgbClr val="202124"/>
-              </a:buClr>
-              <a:buSzPts val="1200"/>
-              <a:buFont typeface="Lato"/>
-              <a:buNone/>
-            </a:pPr>
-            <a:r>
-              <a:rPr b="0" i="0" lang="en-US" sz="1200" u="none" cap="none" strike="noStrike">
-                <a:solidFill>
-                  <a:srgbClr val="202124"/>
-                </a:solidFill>
-                <a:latin typeface="Lato"/>
-                <a:ea typeface="Lato"/>
-                <a:cs typeface="Lato"/>
-                <a:sym typeface="Lato"/>
-              </a:rPr>
-              <a:t>devops_glossary.md</a:t>
-            </a:r>
-            <a:endParaRPr b="0" i="0" sz="1200" u="none" cap="none" strike="noStrike">
-              <a:solidFill>
-                <a:srgbClr val="202124"/>
-              </a:solidFill>
-              <a:latin typeface="Lato"/>
-              <a:ea typeface="Lato"/>
-              <a:cs typeface="Lato"/>
-              <a:sym typeface="Lato"/>
-            </a:endParaRPr>
-          </a:p>
-          <a:p>
-            <a:pPr indent="0" lvl="0" marL="0" marR="0" rtl="0" algn="l">
-              <a:spcBef>
-                <a:spcPts val="0"/>
-              </a:spcBef>
-              <a:spcAft>
-                <a:spcPts val="0"/>
-              </a:spcAft>
-              <a:buClr>
-                <a:srgbClr val="202124"/>
-              </a:buClr>
-              <a:buSzPts val="1200"/>
-              <a:buFont typeface="Lato"/>
-              <a:buNone/>
-            </a:pPr>
-            <a:r>
-              <a:rPr b="0" i="0" lang="en-US" sz="1200" u="none" cap="none" strike="noStrike">
-                <a:solidFill>
-                  <a:srgbClr val="202124"/>
-                </a:solidFill>
-                <a:latin typeface="Lato"/>
-                <a:ea typeface="Lato"/>
-                <a:cs typeface="Lato"/>
-                <a:sym typeface="Lato"/>
-              </a:rPr>
-              <a:t>Defines trace, span, OpenTelemetry, Langfuse, vector, ChromaDB, top-k, Ollama.</a:t>
-            </a:r>
-            <a:endParaRPr b="0" i="0" sz="1200" u="none" cap="none" strike="noStrike">
-              <a:solidFill>
-                <a:srgbClr val="202124"/>
-              </a:solidFill>
-              <a:latin typeface="Lato"/>
-              <a:ea typeface="Lato"/>
-              <a:cs typeface="Lato"/>
-              <a:sym typeface="Lato"/>
-            </a:endParaRPr>
-          </a:p>
-          <a:p>
-            <a:pPr indent="0" lvl="0" marL="0" marR="0" rtl="0" algn="l">
-              <a:spcBef>
-                <a:spcPts val="0"/>
-              </a:spcBef>
-              <a:spcAft>
-                <a:spcPts val="0"/>
-              </a:spcAft>
-              <a:buClr>
-                <a:srgbClr val="202124"/>
-              </a:buClr>
-              <a:buSzPts val="1200"/>
-              <a:buFont typeface="Lato"/>
-              <a:buNone/>
-            </a:pPr>
-            <a:r>
-              <a:rPr b="0" i="0" lang="en-US" sz="1200" u="none" cap="none" strike="noStrike">
-                <a:solidFill>
-                  <a:srgbClr val="202124"/>
-                </a:solidFill>
-                <a:latin typeface="Lato"/>
-                <a:ea typeface="Lato"/>
-                <a:cs typeface="Lato"/>
-                <a:sym typeface="Lato"/>
-              </a:rPr>
-              <a:t>The vocabulary.</a:t>
-            </a:r>
-            <a:endParaRPr b="0" i="0" sz="1200" u="none" cap="none" strike="noStrike">
-              <a:solidFill>
-                <a:schemeClr val="dk1"/>
-              </a:solidFill>
-              <a:latin typeface="Calibri"/>
-              <a:ea typeface="Calibri"/>
-              <a:cs typeface="Calibri"/>
-              <a:sym typeface="Calibri"/>
-            </a:endParaRPr>
-          </a:p>
-        </p:txBody>
-      </p:sp>
-      <p:pic>
-        <p:nvPicPr>
-          <p:cNvPr descr="preencoded.png" id="245" name="Google Shape;245;p11"/>
-          <p:cNvPicPr preferRelativeResize="0"/>
-          <p:nvPr/>
-        </p:nvPicPr>
-        <p:blipFill rotWithShape="1">
-          <a:blip r:embed="rId6">
-            <a:alphaModFix/>
-          </a:blip>
-          <a:srcRect b="0" l="0" r="0" t="0"/>
-          <a:stretch/>
-        </p:blipFill>
-        <p:spPr>
-          <a:xfrm>
-            <a:off x="6217920" y="2377440"/>
-            <a:ext cx="548640" cy="548640"/>
-          </a:xfrm>
-          <a:prstGeom prst="rect">
-            <a:avLst/>
-          </a:prstGeom>
-          <a:noFill/>
-          <a:ln>
-            <a:noFill/>
-          </a:ln>
-        </p:spPr>
-      </p:pic>
-      <p:sp>
-        <p:nvSpPr>
-          <p:cNvPr id="246" name="Google Shape;246;p11"/>
-          <p:cNvSpPr/>
-          <p:nvPr/>
-        </p:nvSpPr>
-        <p:spPr>
-          <a:xfrm>
-            <a:off x="6949440" y="2331720"/>
-            <a:ext cx="4937760" cy="411480"/>
-          </a:xfrm>
-          <a:prstGeom prst="rect">
-            <a:avLst/>
-          </a:prstGeom>
-          <a:noFill/>
-          <a:ln>
-            <a:noFill/>
-          </a:ln>
-        </p:spPr>
-        <p:txBody>
-          <a:bodyPr anchorCtr="0" anchor="ctr" bIns="0" lIns="0" spcFirstLastPara="1" rIns="0" wrap="square" tIns="0">
-            <a:noAutofit/>
-          </a:bodyPr>
-          <a:lstStyle/>
-          <a:p>
-            <a:pPr indent="0" lvl="0" marL="0" marR="0" rtl="0" algn="l">
-              <a:spcBef>
-                <a:spcPts val="0"/>
-              </a:spcBef>
-              <a:spcAft>
-                <a:spcPts val="0"/>
-              </a:spcAft>
-              <a:buClr>
-                <a:srgbClr val="0D1B2A"/>
-              </a:buClr>
-              <a:buSzPts val="1800"/>
-              <a:buFont typeface="Spectral"/>
-              <a:buNone/>
-            </a:pPr>
-            <a:r>
-              <a:rPr b="1" i="0" lang="en-US" sz="1800" u="none" cap="none" strike="noStrike">
-                <a:solidFill>
-                  <a:srgbClr val="0D1B2A"/>
-                </a:solidFill>
-                <a:latin typeface="Spectral"/>
-                <a:ea typeface="Spectral"/>
-                <a:cs typeface="Spectral"/>
-                <a:sym typeface="Spectral"/>
-              </a:rPr>
-              <a:t>llm_observability.md</a:t>
-            </a:r>
-            <a:endParaRPr b="0" i="0" sz="1800" u="none" cap="none" strike="noStrike">
-              <a:solidFill>
-                <a:schemeClr val="dk1"/>
-              </a:solidFill>
-              <a:latin typeface="Calibri"/>
-              <a:ea typeface="Calibri"/>
-              <a:cs typeface="Calibri"/>
-              <a:sym typeface="Calibri"/>
-            </a:endParaRPr>
-          </a:p>
-        </p:txBody>
-      </p:sp>
-      <p:sp>
-        <p:nvSpPr>
-          <p:cNvPr id="247" name="Google Shape;247;p11"/>
-          <p:cNvSpPr/>
-          <p:nvPr/>
-        </p:nvSpPr>
-        <p:spPr>
-          <a:xfrm>
-            <a:off x="6949440" y="2788920"/>
-            <a:ext cx="4937760" cy="1280160"/>
-          </a:xfrm>
-          <a:prstGeom prst="rect">
-            <a:avLst/>
-          </a:prstGeom>
-          <a:noFill/>
-          <a:ln>
-            <a:noFill/>
-          </a:ln>
-        </p:spPr>
-        <p:txBody>
-          <a:bodyPr anchorCtr="0" anchor="t" bIns="0" lIns="0" spcFirstLastPara="1" rIns="0" wrap="square" tIns="0">
-            <a:noAutofit/>
-          </a:bodyPr>
-          <a:lstStyle/>
-          <a:p>
-            <a:pPr indent="0" lvl="0" marL="0" marR="0" rtl="0" algn="l">
-              <a:spcBef>
-                <a:spcPts val="0"/>
-              </a:spcBef>
-              <a:spcAft>
-                <a:spcPts val="0"/>
-              </a:spcAft>
-              <a:buClr>
-                <a:srgbClr val="202124"/>
-              </a:buClr>
-              <a:buSzPts val="1200"/>
-              <a:buFont typeface="Lato"/>
-              <a:buNone/>
-            </a:pPr>
-            <a:r>
-              <a:rPr b="0" i="0" lang="en-US" sz="1200" u="none" cap="none" strike="noStrike">
-                <a:solidFill>
-                  <a:srgbClr val="202124"/>
-                </a:solidFill>
-                <a:latin typeface="Lato"/>
-                <a:ea typeface="Lato"/>
-                <a:cs typeface="Lato"/>
-                <a:sym typeface="Lato"/>
-              </a:rPr>
-              <a:t>Why APMs miss LLM failures.</a:t>
-            </a:r>
-            <a:endParaRPr b="0" i="0" sz="1200" u="none" cap="none" strike="noStrike">
-              <a:solidFill>
-                <a:srgbClr val="202124"/>
-              </a:solidFill>
-              <a:latin typeface="Lato"/>
-              <a:ea typeface="Lato"/>
-              <a:cs typeface="Lato"/>
-              <a:sym typeface="Lato"/>
-            </a:endParaRPr>
-          </a:p>
-          <a:p>
-            <a:pPr indent="0" lvl="0" marL="0" marR="0" rtl="0" algn="l">
-              <a:spcBef>
-                <a:spcPts val="0"/>
-              </a:spcBef>
-              <a:spcAft>
-                <a:spcPts val="0"/>
-              </a:spcAft>
-              <a:buClr>
-                <a:srgbClr val="202124"/>
-              </a:buClr>
-              <a:buSzPts val="1200"/>
-              <a:buFont typeface="Lato"/>
-              <a:buNone/>
-            </a:pPr>
-            <a:r>
-              <a:rPr b="0" i="0" lang="en-US" sz="1200" u="none" cap="none" strike="noStrike">
-                <a:solidFill>
-                  <a:srgbClr val="202124"/>
-                </a:solidFill>
-                <a:latin typeface="Lato"/>
-                <a:ea typeface="Lato"/>
-                <a:cs typeface="Lato"/>
-                <a:sym typeface="Lato"/>
-              </a:rPr>
-              <a:t>The three signals: cost, quality, grounding.</a:t>
-            </a:r>
-            <a:endParaRPr b="0" i="0" sz="1200" u="none" cap="none" strike="noStrike">
-              <a:solidFill>
-                <a:schemeClr val="dk1"/>
-              </a:solidFill>
-              <a:latin typeface="Calibri"/>
-              <a:ea typeface="Calibri"/>
-              <a:cs typeface="Calibri"/>
-              <a:sym typeface="Calibri"/>
-            </a:endParaRPr>
-          </a:p>
-        </p:txBody>
-      </p:sp>
-      <p:pic>
-        <p:nvPicPr>
-          <p:cNvPr descr="preencoded.png" id="248" name="Google Shape;248;p11"/>
-          <p:cNvPicPr preferRelativeResize="0"/>
-          <p:nvPr/>
-        </p:nvPicPr>
-        <p:blipFill rotWithShape="1">
-          <a:blip r:embed="rId7">
-            <a:alphaModFix/>
-          </a:blip>
-          <a:srcRect b="0" l="0" r="0" t="0"/>
-          <a:stretch/>
-        </p:blipFill>
-        <p:spPr>
-          <a:xfrm>
-            <a:off x="502920" y="4206240"/>
-            <a:ext cx="548640" cy="548640"/>
-          </a:xfrm>
-          <a:prstGeom prst="rect">
-            <a:avLst/>
-          </a:prstGeom>
-          <a:noFill/>
-          <a:ln>
-            <a:noFill/>
-          </a:ln>
-        </p:spPr>
-      </p:pic>
-      <p:sp>
-        <p:nvSpPr>
-          <p:cNvPr id="249" name="Google Shape;249;p11"/>
-          <p:cNvSpPr/>
-          <p:nvPr/>
-        </p:nvSpPr>
-        <p:spPr>
-          <a:xfrm>
-            <a:off x="1234440" y="4160520"/>
-            <a:ext cx="4937760" cy="411480"/>
-          </a:xfrm>
-          <a:prstGeom prst="rect">
-            <a:avLst/>
-          </a:prstGeom>
-          <a:noFill/>
-          <a:ln>
-            <a:noFill/>
-          </a:ln>
-        </p:spPr>
-        <p:txBody>
-          <a:bodyPr anchorCtr="0" anchor="ctr" bIns="0" lIns="0" spcFirstLastPara="1" rIns="0" wrap="square" tIns="0">
-            <a:noAutofit/>
-          </a:bodyPr>
-          <a:lstStyle/>
-          <a:p>
-            <a:pPr indent="0" lvl="0" marL="0" marR="0" rtl="0" algn="l">
-              <a:spcBef>
-                <a:spcPts val="0"/>
-              </a:spcBef>
-              <a:spcAft>
-                <a:spcPts val="0"/>
-              </a:spcAft>
-              <a:buClr>
-                <a:srgbClr val="0D1B2A"/>
-              </a:buClr>
-              <a:buSzPts val="1800"/>
-              <a:buFont typeface="Spectral"/>
-              <a:buNone/>
-            </a:pPr>
-            <a:r>
-              <a:rPr b="1" i="0" lang="en-US" sz="1800" u="none" cap="none" strike="noStrike">
-                <a:solidFill>
-                  <a:srgbClr val="0D1B2A"/>
-                </a:solidFill>
-                <a:latin typeface="Spectral"/>
-                <a:ea typeface="Spectral"/>
-                <a:cs typeface="Spectral"/>
-                <a:sym typeface="Spectral"/>
-              </a:rPr>
-              <a:t>rag_patterns.md</a:t>
-            </a:r>
-            <a:endParaRPr b="0" i="0" sz="1800" u="none" cap="none" strike="noStrike">
-              <a:solidFill>
-                <a:schemeClr val="dk1"/>
-              </a:solidFill>
-              <a:latin typeface="Calibri"/>
-              <a:ea typeface="Calibri"/>
-              <a:cs typeface="Calibri"/>
-              <a:sym typeface="Calibri"/>
-            </a:endParaRPr>
-          </a:p>
-        </p:txBody>
-      </p:sp>
-      <p:sp>
-        <p:nvSpPr>
-          <p:cNvPr id="250" name="Google Shape;250;p11"/>
-          <p:cNvSpPr/>
-          <p:nvPr/>
-        </p:nvSpPr>
-        <p:spPr>
-          <a:xfrm>
-            <a:off x="1234440" y="4617720"/>
-            <a:ext cx="4937760" cy="1280160"/>
-          </a:xfrm>
-          <a:prstGeom prst="rect">
-            <a:avLst/>
-          </a:prstGeom>
-          <a:noFill/>
-          <a:ln>
-            <a:noFill/>
-          </a:ln>
-        </p:spPr>
-        <p:txBody>
-          <a:bodyPr anchorCtr="0" anchor="t" bIns="0" lIns="0" spcFirstLastPara="1" rIns="0" wrap="square" tIns="0">
-            <a:noAutofit/>
-          </a:bodyPr>
-          <a:lstStyle/>
-          <a:p>
-            <a:pPr indent="0" lvl="0" marL="0" marR="0" rtl="0" algn="l">
-              <a:spcBef>
-                <a:spcPts val="0"/>
-              </a:spcBef>
-              <a:spcAft>
-                <a:spcPts val="0"/>
-              </a:spcAft>
-              <a:buClr>
-                <a:srgbClr val="202124"/>
-              </a:buClr>
-              <a:buSzPts val="1200"/>
-              <a:buFont typeface="Lato"/>
-              <a:buNone/>
-            </a:pPr>
-            <a:r>
-              <a:rPr b="0" i="0" lang="en-US" sz="1200" u="none" cap="none" strike="noStrike">
-                <a:solidFill>
-                  <a:srgbClr val="202124"/>
-                </a:solidFill>
-                <a:latin typeface="Lato"/>
-                <a:ea typeface="Lato"/>
-                <a:cs typeface="Lato"/>
-                <a:sym typeface="Lato"/>
-              </a:rPr>
-              <a:t>Five RAG stages and how each fails. The work-backwards-through-the-trace debug flow.</a:t>
-            </a:r>
-            <a:endParaRPr b="0" i="0" sz="1200" u="none" cap="none" strike="noStrike">
-              <a:solidFill>
-                <a:schemeClr val="dk1"/>
-              </a:solidFill>
-              <a:latin typeface="Calibri"/>
-              <a:ea typeface="Calibri"/>
-              <a:cs typeface="Calibri"/>
-              <a:sym typeface="Calibri"/>
-            </a:endParaRPr>
-          </a:p>
-        </p:txBody>
-      </p:sp>
-      <p:pic>
-        <p:nvPicPr>
-          <p:cNvPr descr="preencoded.png" id="251" name="Google Shape;251;p11"/>
-          <p:cNvPicPr preferRelativeResize="0"/>
-          <p:nvPr/>
-        </p:nvPicPr>
-        <p:blipFill rotWithShape="1">
-          <a:blip r:embed="rId8">
-            <a:alphaModFix/>
-          </a:blip>
-          <a:srcRect b="0" l="0" r="0" t="0"/>
-          <a:stretch/>
-        </p:blipFill>
-        <p:spPr>
-          <a:xfrm>
-            <a:off x="6217920" y="4206240"/>
-            <a:ext cx="548640" cy="548640"/>
-          </a:xfrm>
-          <a:prstGeom prst="rect">
-            <a:avLst/>
-          </a:prstGeom>
-          <a:noFill/>
-          <a:ln>
-            <a:noFill/>
-          </a:ln>
-        </p:spPr>
-      </p:pic>
-      <p:sp>
-        <p:nvSpPr>
-          <p:cNvPr id="252" name="Google Shape;252;p11"/>
-          <p:cNvSpPr/>
-          <p:nvPr/>
-        </p:nvSpPr>
-        <p:spPr>
-          <a:xfrm>
-            <a:off x="6949440" y="4160520"/>
-            <a:ext cx="4937760" cy="411480"/>
-          </a:xfrm>
-          <a:prstGeom prst="rect">
-            <a:avLst/>
-          </a:prstGeom>
-          <a:noFill/>
-          <a:ln>
-            <a:noFill/>
-          </a:ln>
-        </p:spPr>
-        <p:txBody>
-          <a:bodyPr anchorCtr="0" anchor="ctr" bIns="0" lIns="0" spcFirstLastPara="1" rIns="0" wrap="square" tIns="0">
-            <a:noAutofit/>
-          </a:bodyPr>
-          <a:lstStyle/>
-          <a:p>
-            <a:pPr indent="0" lvl="0" marL="0" marR="0" rtl="0" algn="l">
-              <a:spcBef>
-                <a:spcPts val="0"/>
-              </a:spcBef>
-              <a:spcAft>
-                <a:spcPts val="0"/>
-              </a:spcAft>
-              <a:buClr>
-                <a:srgbClr val="0D1B2A"/>
-              </a:buClr>
-              <a:buSzPts val="1800"/>
-              <a:buFont typeface="Spectral"/>
-              <a:buNone/>
-            </a:pPr>
-            <a:r>
-              <a:rPr b="1" i="0" lang="en-US" sz="1800" u="none" cap="none" strike="noStrike">
-                <a:solidFill>
-                  <a:srgbClr val="0D1B2A"/>
-                </a:solidFill>
-                <a:latin typeface="Spectral"/>
-                <a:ea typeface="Spectral"/>
-                <a:cs typeface="Spectral"/>
-                <a:sym typeface="Spectral"/>
-              </a:rPr>
-              <a:t>All three are in your packet</a:t>
-            </a:r>
-            <a:endParaRPr b="0" i="0" sz="1800" u="none" cap="none" strike="noStrike">
-              <a:solidFill>
-                <a:schemeClr val="dk1"/>
-              </a:solidFill>
-              <a:latin typeface="Calibri"/>
-              <a:ea typeface="Calibri"/>
-              <a:cs typeface="Calibri"/>
-              <a:sym typeface="Calibri"/>
-            </a:endParaRPr>
-          </a:p>
-        </p:txBody>
-      </p:sp>
-      <p:sp>
-        <p:nvSpPr>
-          <p:cNvPr id="253" name="Google Shape;253;p11"/>
-          <p:cNvSpPr/>
-          <p:nvPr/>
-        </p:nvSpPr>
-        <p:spPr>
-          <a:xfrm>
-            <a:off x="6949440" y="4617720"/>
-            <a:ext cx="4937760" cy="1280160"/>
-          </a:xfrm>
-          <a:prstGeom prst="rect">
-            <a:avLst/>
-          </a:prstGeom>
-          <a:noFill/>
-          <a:ln>
-            <a:noFill/>
-          </a:ln>
-        </p:spPr>
-        <p:txBody>
-          <a:bodyPr anchorCtr="0" anchor="t" bIns="0" lIns="0" spcFirstLastPara="1" rIns="0" wrap="square" tIns="0">
-            <a:noAutofit/>
-          </a:bodyPr>
-          <a:lstStyle/>
-          <a:p>
-            <a:pPr indent="0" lvl="0" marL="0" marR="0" rtl="0" algn="l">
-              <a:spcBef>
-                <a:spcPts val="0"/>
-              </a:spcBef>
-              <a:spcAft>
-                <a:spcPts val="0"/>
-              </a:spcAft>
-              <a:buClr>
-                <a:srgbClr val="202124"/>
-              </a:buClr>
-              <a:buSzPts val="1200"/>
-              <a:buFont typeface="Lato"/>
-              <a:buNone/>
-            </a:pPr>
-            <a:r>
-              <a:rPr b="0" i="0" lang="en-US" sz="1200" u="none" cap="none" strike="noStrike">
-                <a:solidFill>
-                  <a:srgbClr val="202124"/>
-                </a:solidFill>
-                <a:latin typeface="Lato"/>
-                <a:ea typeface="Lato"/>
-                <a:cs typeface="Lato"/>
-                <a:sym typeface="Lato"/>
-              </a:rPr>
-              <a:t>Print copies. Refer back when you ask: did the model use the right source?</a:t>
-            </a:r>
-            <a:endParaRPr b="0" i="0" sz="1200" u="none" cap="none" strike="noStrike">
-              <a:solidFill>
-                <a:schemeClr val="dk1"/>
-              </a:solidFill>
-              <a:latin typeface="Calibri"/>
-              <a:ea typeface="Calibri"/>
-              <a:cs typeface="Calibri"/>
-              <a:sym typeface="Calibri"/>
-            </a:endParaRPr>
-          </a:p>
-        </p:txBody>
-      </p:sp>
-      <p:pic>
-        <p:nvPicPr>
-          <p:cNvPr id="254" name="Google Shape;254;p11" title="Gemini_Generated_Image_rbdzoirbdzoirbdz.png"/>
-          <p:cNvPicPr preferRelativeResize="0"/>
-          <p:nvPr/>
-        </p:nvPicPr>
-        <p:blipFill rotWithShape="1">
-          <a:blip r:embed="rId9">
-            <a:alphaModFix/>
-          </a:blip>
-          <a:srcRect b="33061" l="22742" r="28149" t="10923"/>
-          <a:stretch/>
-        </p:blipFill>
-        <p:spPr>
-          <a:xfrm>
-            <a:off x="9885440" y="6291673"/>
-            <a:ext cx="1727432" cy="492600"/>
-          </a:xfrm>
-          <a:prstGeom prst="rect">
-            <a:avLst/>
-          </a:prstGeom>
-          <a:noFill/>
-          <a:ln>
-            <a:noFill/>
-          </a:ln>
-        </p:spPr>
-      </p:pic>
-    </p:spTree>
-  </p:cSld>
-  <p:clrMapOvr>
-    <a:masterClrMapping/>
-  </p:clrMapOvr>
-</p:sld>
-</file>
-
 <file path=ppt/slides/slide3.xml><?xml version="1.0" encoding="utf-8"?>
 <p:sld xmlns:a="http://schemas.openxmlformats.org/drawingml/2006/main" xmlns:r="http://schemas.openxmlformats.org/officeDocument/2006/relationships" xmlns:mc="http://schemas.openxmlformats.org/markup-compatibility/2006" xmlns:mv="urn:schemas-microsoft-com:mac:vml" xmlns:p="http://schemas.openxmlformats.org/presentationml/2006/main" xmlns:c="http://schemas.openxmlformats.org/drawingml/2006/chart" xmlns:dgm="http://schemas.openxmlformats.org/drawingml/2006/diagram" xmlns:o="urn:schemas-microsoft-com:office:office" xmlns:v="urn:schemas-microsoft-com:vml" xmlns:pvml="urn:schemas-microsoft-com:office:powerpoint" xmlns:com="http://schemas.openxmlformats.org/drawingml/2006/compatibility" xmlns:p14="http://schemas.microsoft.com/office/powerpoint/2010/main" xmlns:p15="http://schemas.microsoft.com/office/powerpoint/2012/main" xmlns:ahyp="http://schemas.microsoft.com/office/drawing/2018/hyperlinkcolor">
   <p:cSld>
@@ -27877,7 +23360,19 @@
                 <a:cs typeface="Lato"/>
                 <a:sym typeface="Lato"/>
               </a:rPr>
-              <a:t>Your Phase 1 scores become training data for an automated judge. The judge applies your rubric at scale, across thousands of queries.</a:t>
+              <a:t>Your Phase 1 scores become training data for an automated judge. The judge applies your rubric at scale, across thousands of queries</a:t>
+            </a:r>
+            <a:r>
+              <a:rPr lang="en-US" sz="1300">
+                <a:solidFill>
+                  <a:srgbClr val="202124"/>
+                </a:solidFill>
+                <a:latin typeface="Lato"/>
+                <a:ea typeface="Lato"/>
+                <a:cs typeface="Lato"/>
+                <a:sym typeface="Lato"/>
+              </a:rPr>
+              <a:t xml:space="preserve"> - ML Classification.</a:t>
             </a:r>
             <a:endParaRPr b="0" i="0" sz="1300" u="none" cap="none" strike="noStrike">
               <a:solidFill>
@@ -28261,7 +23756,78 @@
                 <a:cs typeface="Lato"/>
                 <a:sym typeface="Lato"/>
               </a:rPr>
-              <a:t>observability of the live system. Traces, costs, drift. This is what we build today. The next 90 minutes lives here.</a:t>
+              <a:t xml:space="preserve">observability of the live system. Traces, costs, drift. </a:t>
+            </a:r>
+            <a:endParaRPr b="0" i="0" sz="1300" u="none" cap="none" strike="noStrike">
+              <a:solidFill>
+                <a:srgbClr val="202124"/>
+              </a:solidFill>
+              <a:latin typeface="Lato"/>
+              <a:ea typeface="Lato"/>
+              <a:cs typeface="Lato"/>
+              <a:sym typeface="Lato"/>
+            </a:endParaRPr>
+          </a:p>
+          <a:p>
+            <a:pPr indent="0" lvl="0" marL="0" marR="0" rtl="0" algn="l">
+              <a:lnSpc>
+                <a:spcPct val="100000"/>
+              </a:lnSpc>
+              <a:spcBef>
+                <a:spcPts val="0"/>
+              </a:spcBef>
+              <a:spcAft>
+                <a:spcPts val="0"/>
+              </a:spcAft>
+              <a:buClr>
+                <a:srgbClr val="202124"/>
+              </a:buClr>
+              <a:buSzPts val="1300"/>
+              <a:buFont typeface="Lato"/>
+              <a:buNone/>
+            </a:pPr>
+            <a:r>
+              <a:t/>
+            </a:r>
+            <a:endParaRPr sz="1300">
+              <a:solidFill>
+                <a:srgbClr val="202124"/>
+              </a:solidFill>
+              <a:latin typeface="Lato"/>
+              <a:ea typeface="Lato"/>
+              <a:cs typeface="Lato"/>
+              <a:sym typeface="Lato"/>
+            </a:endParaRPr>
+          </a:p>
+          <a:p>
+            <a:pPr indent="0" lvl="0" marL="0" marR="0" rtl="0" algn="l">
+              <a:lnSpc>
+                <a:spcPct val="100000"/>
+              </a:lnSpc>
+              <a:spcBef>
+                <a:spcPts val="0"/>
+              </a:spcBef>
+              <a:spcAft>
+                <a:spcPts val="0"/>
+              </a:spcAft>
+              <a:buClr>
+                <a:srgbClr val="202124"/>
+              </a:buClr>
+              <a:buSzPts val="1300"/>
+              <a:buFont typeface="Lato"/>
+              <a:buNone/>
+            </a:pPr>
+            <a:r>
+              <a:rPr b="0" i="0" lang="en-US" sz="1300" u="none" cap="none" strike="noStrike">
+                <a:solidFill>
+                  <a:srgbClr val="202124"/>
+                </a:solidFill>
+                <a:latin typeface="Lato"/>
+                <a:ea typeface="Lato"/>
+                <a:cs typeface="Lato"/>
+                <a:sym typeface="Lato"/>
+              </a:rPr>
+              <a:t>This is what we build today. The next 90 minutes lives here.</a:t>
             </a:r>
             <a:endParaRPr b="0" i="0" sz="1300" u="none" cap="none" strike="noStrike">
               <a:solidFill>
@@ -30446,7 +26012,31 @@
                 <a:cs typeface="Lato"/>
                 <a:sym typeface="Lato"/>
               </a:rPr>
-              <a:t>Every call has variable cost. Token counts per endpoint, per user cohort, per feature flag are the only honest cost model.</a:t>
+              <a:t xml:space="preserve">Every call has variable cost. Token counts per endpoint, per user cohort, per feature flag are </a:t>
+            </a:r>
+            <a:r>
+              <a:rPr lang="en-US" sz="1300">
+                <a:solidFill>
+                  <a:srgbClr val="202124"/>
+                </a:solidFill>
+                <a:latin typeface="Lato"/>
+                <a:ea typeface="Lato"/>
+                <a:cs typeface="Lato"/>
+                <a:sym typeface="Lato"/>
+              </a:rPr>
+              <a:t xml:space="preserve">a </a:t>
+            </a:r>
+            <a:r>
+              <a:rPr b="0" i="0" lang="en-US" sz="1300" u="none" cap="none" strike="noStrike">
+                <a:solidFill>
+                  <a:srgbClr val="202124"/>
+                </a:solidFill>
+                <a:latin typeface="Lato"/>
+                <a:ea typeface="Lato"/>
+                <a:cs typeface="Lato"/>
+                <a:sym typeface="Lato"/>
+              </a:rPr>
+              <a:t>honest cost model.</a:t>
             </a:r>
             <a:endParaRPr b="0" i="0" sz="1300" u="none" cap="none" strike="noStrike">
               <a:solidFill>
@@ -30697,7 +26287,7 @@
                 <a:cs typeface="Lato"/>
                 <a:sym typeface="Lato"/>
               </a:rPr>
-              <a:t>Prompt + completion content is the only way to know WHY the model answered the way it did. Without it, debugging is guessing.</a:t>
+              <a:t>Prompt + completion content is the way to know WHY the model answered the way it did. Without it, debugging is guessing.</a:t>
             </a:r>
             <a:endParaRPr b="0" i="0" sz="1300" u="none" cap="none" strike="noStrike">
               <a:solidFill>
@@ -33512,7 +29102,7 @@
                 <a:cs typeface="Spectral"/>
                 <a:sym typeface="Spectral"/>
               </a:rPr>
-              <a:t>Four tools. Each does one thing well.</a:t>
+              <a:t>Five tools. Each does one thing well.</a:t>
             </a:r>
             <a:endParaRPr b="0" i="0" sz="4000" u="none" cap="none" strike="noStrike">
               <a:solidFill>
@@ -35193,7 +30783,7 @@
       <p:sp>
         <p:nvSpPr>
           <p:cNvPr id="203" name="Google Shape;203;p10">
-            <a:hlinkClick r:id="rId3"/>
+            <a:hlinkClick r:id="rId4"/>
           </p:cNvPr>
           <p:cNvSpPr/>
           <p:nvPr/>
@@ -35240,7 +30830,7 @@
                 <a:ea typeface="Lato"/>
                 <a:cs typeface="Lato"/>
                 <a:sym typeface="Lato"/>
-                <a:hlinkClick r:id="rId4"/>
+                <a:hlinkClick r:id="rId5"/>
               </a:rPr>
               <a:t>www.arsinnovate.com</a:t>
             </a:r>
@@ -36257,7 +31847,31 @@
                 <a:cs typeface="Spectral"/>
                 <a:sym typeface="Spectral"/>
               </a:rPr>
-              <a:t>Step 3 — OpenTelemetry + Jaeger</a:t>
+              <a:t xml:space="preserve">Step 3 — </a:t>
+            </a:r>
+            <a:r>
+              <a:rPr b="1" i="0" lang="en-US" sz="1600" u="none" cap="none" strike="noStrike">
+                <a:solidFill>
+                  <a:srgbClr val="0D1B2A"/>
+                </a:solidFill>
+                <a:latin typeface="Spectral"/>
+                <a:ea typeface="Spectral"/>
+                <a:cs typeface="Spectral"/>
+                <a:sym typeface="Spectral"/>
+              </a:rPr>
+              <a:t>OpenTelemetry + Jaeger</a:t>
+            </a:r>
+            <a:r>
+              <a:rPr b="1" i="0" lang="en-US" sz="1600" u="none" cap="none" strike="noStrike">
+                <a:solidFill>
+                  <a:srgbClr val="0D1B2A"/>
+                </a:solidFill>
+                <a:latin typeface="Spectral"/>
+                <a:ea typeface="Spectral"/>
+                <a:cs typeface="Spectral"/>
+                <a:sym typeface="Spectral"/>
+              </a:rPr>
+              <a:t xml:space="preserve"> </a:t>
             </a:r>
             <a:endParaRPr b="0" i="0" sz="1600" u="none" cap="none" strike="noStrike">
               <a:solidFill>
@@ -36817,7 +32431,7 @@
           <p:nvPr/>
         </p:nvPicPr>
         <p:blipFill rotWithShape="1">
-          <a:blip r:embed="rId5">
+          <a:blip r:embed="rId6">
             <a:alphaModFix/>
           </a:blip>
           <a:srcRect b="33061" l="22742" r="28149" t="10923"/>
@@ -37525,7 +33139,7 @@
                 <a:cs typeface="Spectral"/>
                 <a:sym typeface="Spectral"/>
               </a:rPr>
-              <a:t>Pair up — on purpose at Steps 1 + 4</a:t>
+              <a:t>Pair up if Docker died</a:t>
             </a:r>
             <a:endParaRPr b="0" i="0" sz="1800" u="none" cap="none" strike="noStrike">
               <a:solidFill>
@@ -37588,7 +33202,7 @@
                 <a:cs typeface="Lato"/>
                 <a:sym typeface="Lato"/>
               </a:rPr>
-              <a:t xml:space="preserve">Steps 1 + 4 are designed for pair/group discussion. Find a neighbor now — demo-watchers and laptop-runners both contribute. </a:t>
+              <a:t xml:space="preserve">If conference wifi slow, you may be stuck. if trying to download Docker </a:t>
             </a:r>
             <a:endParaRPr b="0" i="0" sz="1200" u="none" cap="none" strike="noStrike">
               <a:solidFill>
@@ -37625,7 +33239,7 @@
                 <a:cs typeface="Lato"/>
                 <a:sym typeface="Lato"/>
               </a:rPr>
-              <a:t>If your setup didn’t finish, you’re a demo-watcher today. Your packet keeps you in the game.</a:t>
+              <a:t>Share a laptop with a neighbor — learning is better than lonely.</a:t>
             </a:r>
             <a:endParaRPr b="0" i="0" sz="1200" u="none" cap="none" strike="noStrike">
               <a:solidFill>

</xml_diff>